<commit_message>
UPD:  BrainScanAI presentation with new content and design enhancements
</commit_message>
<xml_diff>
--- a/powerpoint/BrainScanAI.pptx
+++ b/powerpoint/BrainScanAI.pptx
@@ -16,9 +16,10 @@
     <p:sldId id="264" r:id="rId10"/>
     <p:sldId id="265" r:id="rId11"/>
     <p:sldId id="266" r:id="rId12"/>
+    <p:sldId id="267" r:id="rId13"/>
   </p:sldIdLst>
   <p:notesMasterIdLst>
-    <p:notesMasterId r:id="rId13"/>
+    <p:notesMasterId r:id="rId14"/>
   </p:notesMasterIdLst>
   <p:sldSz cx="9144000" cy="5143500"/>
   <p:notesSz cx="5143500" cy="9144000"/>
@@ -1028,7 +1029,7 @@
           <a:p>
             <a:r>
               <a:rPr lang="en-US" dirty="0"/>
-              <a:t>Ordre d'impact : features d'abord. Sans meilleures features, le reste ne suffira pas.</a:t>
+              <a:t>Message clé : le verrou est technique (qualité features), pas financier. Le compute est quasi gratuit à cette échelle.</a:t>
             </a:r>
             <a:endParaRPr lang="en-US" dirty="0"/>
           </a:p>
@@ -1116,7 +1117,7 @@
           <a:p>
             <a:r>
               <a:rPr lang="en-US" dirty="0"/>
-              <a:t/>
+              <a:t>Ordre d'impact : features d'abord. Sans meilleures features, le reste ne suffira pas.</a:t>
             </a:r>
             <a:endParaRPr lang="en-US" dirty="0"/>
           </a:p>
@@ -1140,6 +1141,94 @@
             <a:fld id="{F7021451-1387-4CA6-816F-3879F97B5CBC}" type="slidenum">
               <a:rPr lang="en-US"/>
               <a:t>11</a:t>
+            </a:fld>
+            <a:endParaRPr lang="en-US"/>
+          </a:p>
+        </p:txBody>
+      </p:sp>
+    </p:spTree>
+    <p:extLst>
+      <p:ext uri="{BB962C8B-B14F-4D97-AF65-F5344CB8AC3E}">
+        <p14:creationId xmlns:p14="http://schemas.microsoft.com/office/powerpoint/2010/main" val="1024086991"/>
+      </p:ext>
+    </p:extLst>
+  </p:cSld>
+  <p:clrMapOvr>
+    <a:masterClrMapping/>
+  </p:clrMapOvr>
+</p:notes>
+</file>
+
+<file path=ppt/notesSlides/notesSlide12.xml><?xml version="1.0" encoding="utf-8"?>
+<p:notes xmlns:a="http://schemas.openxmlformats.org/drawingml/2006/main" xmlns:r="http://schemas.openxmlformats.org/officeDocument/2006/relationships" xmlns:p="http://schemas.openxmlformats.org/presentationml/2006/main">
+  <p:cSld>
+    <p:spTree>
+      <p:nvGrpSpPr>
+        <p:cNvPr id="1" name=""/>
+        <p:cNvGrpSpPr/>
+        <p:nvPr/>
+      </p:nvGrpSpPr>
+      <p:grpSpPr>
+        <a:xfrm>
+          <a:off x="0" y="0"/>
+          <a:ext cx="0" cy="0"/>
+          <a:chOff x="0" y="0"/>
+          <a:chExt cx="0" cy="0"/>
+        </a:xfrm>
+      </p:grpSpPr>
+      <p:sp>
+        <p:nvSpPr>
+          <p:cNvPr id="2" name="Slide Image Placeholder 1"/>
+          <p:cNvSpPr>
+            <a:spLocks noGrp="1" noRot="1" noChangeAspect="1"/>
+          </p:cNvSpPr>
+          <p:nvPr>
+            <p:ph type="sldImg"/>
+          </p:nvPr>
+        </p:nvSpPr>
+        <p:spPr/>
+      </p:sp>
+      <p:sp>
+        <p:nvSpPr>
+          <p:cNvPr id="3" name="Notes Placeholder 2"/>
+          <p:cNvSpPr>
+            <a:spLocks noGrp="1"/>
+          </p:cNvSpPr>
+          <p:nvPr>
+            <p:ph type="body" idx="1"/>
+          </p:nvPr>
+        </p:nvSpPr>
+        <p:spPr/>
+        <p:txBody>
+          <a:bodyPr/>
+          <a:lstStyle/>
+          <a:p>
+            <a:r>
+              <a:rPr lang="en-US" dirty="0"/>
+              <a:t/>
+            </a:r>
+            <a:endParaRPr lang="en-US" dirty="0"/>
+          </a:p>
+        </p:txBody>
+      </p:sp>
+      <p:sp>
+        <p:nvSpPr>
+          <p:cNvPr id="4" name="Slide Number Placeholder 3"/>
+          <p:cNvSpPr>
+            <a:spLocks noGrp="1"/>
+          </p:cNvSpPr>
+          <p:nvPr>
+            <p:ph type="sldNum" sz="quarter" idx="10"/>
+          </p:nvPr>
+        </p:nvSpPr>
+        <p:spPr/>
+        <p:txBody>
+          <a:bodyPr/>
+          <a:lstStyle/>
+          <a:p>
+            <a:fld id="{F7021451-1387-4CA6-816F-3879F97B5CBC}" type="slidenum">
+              <a:rPr lang="en-US"/>
+              <a:t>12</a:t>
             </a:fld>
             <a:endParaRPr lang="en-US"/>
           </a:p>
@@ -1644,7 +1733,7 @@
           <a:p>
             <a:r>
               <a:rPr lang="en-US" dirty="0"/>
-              <a:t>L'arc narratif : biais hérité → correction par les vrais labels → mais bruit qui plafonne le tout. Tout pointe vers la qualité des features.</a:t>
+              <a:t>La slide qui répond à « comment je sais que ce n'est pas du surapprentissage ? » : test isolé, AUC stable sur 5 découpages, hyperparamètres validés, données contrôlées.</a:t>
             </a:r>
             <a:endParaRPr lang="en-US" dirty="0"/>
           </a:p>
@@ -1732,7 +1821,7 @@
           <a:p>
             <a:r>
               <a:rPr lang="en-US" dirty="0"/>
-              <a:t>Le critère 'succès fort' n'est PAS atteint ici — et c'est une information utile, pas un échec du travail.</a:t>
+              <a:t>L'arc narratif : biais hérité → correction par les vrais labels → mais bruit qui plafonne le tout. Tout pointe vers la qualité des features.</a:t>
             </a:r>
             <a:endParaRPr lang="en-US" dirty="0"/>
           </a:p>
@@ -1820,7 +1909,7 @@
           <a:p>
             <a:r>
               <a:rPr lang="en-US" dirty="0"/>
-              <a:t>Message clé : le verrou est technique (qualité features), pas financier. Le compute est quasi gratuit à cette échelle.</a:t>
+              <a:t>Le critère 'succès fort' n'est PAS atteint ici — et c'est une information utile, pas un échec du travail.</a:t>
             </a:r>
             <a:endParaRPr lang="en-US" dirty="0"/>
           </a:p>
@@ -2544,7 +2633,7 @@
                 <a:ea typeface="Calibri" pitchFamily="34" charset="-122"/>
                 <a:cs typeface="Calibri" pitchFamily="34" charset="-120"/>
               </a:rPr>
-              <a:t>Faisable — sous 4 conditions</a:t>
+              <a:t>Passage à l'échelle : l'économie</a:t>
             </a:r>
             <a:endParaRPr lang="en-US" sz="2600" dirty="0"/>
           </a:p>
@@ -2552,18 +2641,57 @@
       </p:sp>
       <p:sp>
         <p:nvSpPr>
-          <p:cNvPr id="5" name="Shape 2"/>
-          <p:cNvSpPr/>
-          <p:nvPr/>
-        </p:nvSpPr>
-        <p:spPr>
-          <a:xfrm>
-            <a:off x="457200" y="1325880"/>
-            <a:ext cx="4023360" cy="1481328"/>
+          <p:cNvPr id="5" name="Text 2"/>
+          <p:cNvSpPr/>
+          <p:nvPr/>
+        </p:nvSpPr>
+        <p:spPr>
+          <a:xfrm>
+            <a:off x="457200" y="1115568"/>
+            <a:ext cx="8229600" cy="365760"/>
+          </a:xfrm>
+          <a:prstGeom prst="rect">
+            <a:avLst/>
+          </a:prstGeom>
+          <a:noFill/>
+          <a:ln/>
+        </p:spPr>
+        <p:txBody>
+          <a:bodyPr wrap="square" lIns="0" tIns="0" rIns="0" bIns="0" rtlCol="0" anchor="ctr"/>
+          <a:lstStyle/>
+          <a:p>
+            <a:pPr indent="0" marL="0">
+              <a:buNone/>
+            </a:pPr>
+            <a:r>
+              <a:rPr lang="en-US" sz="1500" b="1" dirty="0">
+                <a:solidFill>
+                  <a:srgbClr val="1E2D33"/>
+                </a:solidFill>
+                <a:latin typeface="Calibri" pitchFamily="34" charset="0"/>
+                <a:ea typeface="Calibri" pitchFamily="34" charset="-122"/>
+                <a:cs typeface="Calibri" pitchFamily="34" charset="-120"/>
+              </a:rPr>
+              <a:t>Cible : 5 000 € pour labelliser 4 millions d'images.</a:t>
+            </a:r>
+            <a:endParaRPr lang="en-US" sz="1500" dirty="0"/>
+          </a:p>
+        </p:txBody>
+      </p:sp>
+      <p:sp>
+        <p:nvSpPr>
+          <p:cNvPr id="6" name="Shape 3"/>
+          <p:cNvSpPr/>
+          <p:nvPr/>
+        </p:nvSpPr>
+        <p:spPr>
+          <a:xfrm>
+            <a:off x="457200" y="1828800"/>
+            <a:ext cx="2670048" cy="2103120"/>
           </a:xfrm>
           <a:prstGeom prst="roundRect">
             <a:avLst>
-              <a:gd name="adj" fmla="val 4938"/>
+              <a:gd name="adj" fmla="val 3478"/>
             </a:avLst>
           </a:prstGeom>
           <a:solidFill>
@@ -2581,20 +2709,100 @@
       </p:sp>
       <p:sp>
         <p:nvSpPr>
-          <p:cNvPr id="6" name="Shape 3"/>
-          <p:cNvSpPr/>
-          <p:nvPr/>
-        </p:nvSpPr>
-        <p:spPr>
-          <a:xfrm>
-            <a:off x="658368" y="1554480"/>
-            <a:ext cx="512064" cy="512064"/>
-          </a:xfrm>
-          <a:prstGeom prst="ellipse">
-            <a:avLst/>
+          <p:cNvPr id="7" name="Text 4"/>
+          <p:cNvSpPr/>
+          <p:nvPr/>
+        </p:nvSpPr>
+        <p:spPr>
+          <a:xfrm>
+            <a:off x="457200" y="2240280"/>
+            <a:ext cx="2670048" cy="731520"/>
+          </a:xfrm>
+          <a:prstGeom prst="rect">
+            <a:avLst/>
+          </a:prstGeom>
+          <a:noFill/>
+          <a:ln/>
+        </p:spPr>
+        <p:txBody>
+          <a:bodyPr wrap="square" lIns="0" tIns="0" rIns="0" bIns="0" rtlCol="0" anchor="ctr"/>
+          <a:lstStyle/>
+          <a:p>
+            <a:pPr algn="ctr" indent="0" marL="0">
+              <a:buNone/>
+            </a:pPr>
+            <a:r>
+              <a:rPr lang="en-US" sz="4000" b="1" dirty="0">
+                <a:solidFill>
+                  <a:srgbClr val="5B7179"/>
+                </a:solidFill>
+                <a:latin typeface="Calibri" pitchFamily="34" charset="0"/>
+                <a:ea typeface="Calibri" pitchFamily="34" charset="-122"/>
+                <a:cs typeface="Calibri" pitchFamily="34" charset="-120"/>
+              </a:rPr>
+              <a:t>0,20 €</a:t>
+            </a:r>
+            <a:endParaRPr lang="en-US" sz="4000" dirty="0"/>
+          </a:p>
+        </p:txBody>
+      </p:sp>
+      <p:sp>
+        <p:nvSpPr>
+          <p:cNvPr id="8" name="Text 5"/>
+          <p:cNvSpPr/>
+          <p:nvPr/>
+        </p:nvSpPr>
+        <p:spPr>
+          <a:xfrm>
+            <a:off x="457200" y="2953512"/>
+            <a:ext cx="2670048" cy="640080"/>
+          </a:xfrm>
+          <a:prstGeom prst="rect">
+            <a:avLst/>
+          </a:prstGeom>
+          <a:noFill/>
+          <a:ln/>
+        </p:spPr>
+        <p:txBody>
+          <a:bodyPr wrap="square" lIns="0" tIns="0" rIns="0" bIns="0" rtlCol="0" anchor="ctr"/>
+          <a:lstStyle/>
+          <a:p>
+            <a:pPr algn="ctr" indent="0" marL="0">
+              <a:buNone/>
+            </a:pPr>
+            <a:r>
+              <a:rPr lang="en-US" sz="1250" dirty="0">
+                <a:solidFill>
+                  <a:srgbClr val="5B7179"/>
+                </a:solidFill>
+                <a:latin typeface="Calibri" pitchFamily="34" charset="0"/>
+                <a:ea typeface="Calibri" pitchFamily="34" charset="-122"/>
+                <a:cs typeface="Calibri" pitchFamily="34" charset="-120"/>
+              </a:rPr>
+              <a:t>coût/image aujourd'hui (300 € / 1 500)</a:t>
+            </a:r>
+            <a:endParaRPr lang="en-US" sz="1250" dirty="0"/>
+          </a:p>
+        </p:txBody>
+      </p:sp>
+      <p:sp>
+        <p:nvSpPr>
+          <p:cNvPr id="9" name="Shape 6"/>
+          <p:cNvSpPr/>
+          <p:nvPr/>
+        </p:nvSpPr>
+        <p:spPr>
+          <a:xfrm>
+            <a:off x="3236976" y="1828800"/>
+            <a:ext cx="2670048" cy="2103120"/>
+          </a:xfrm>
+          <a:prstGeom prst="roundRect">
+            <a:avLst>
+              <a:gd name="adj" fmla="val 3478"/>
+            </a:avLst>
           </a:prstGeom>
           <a:solidFill>
-            <a:srgbClr val="0C7B8C"/>
+            <a:srgbClr val="EFF6F7"/>
           </a:solidFill>
           <a:ln/>
           <a:effectLst>
@@ -2606,40 +2814,16 @@
           </a:effectLst>
         </p:spPr>
       </p:sp>
-      <p:pic>
-        <p:nvPicPr>
-          <p:cNvPr id="7" name="Image 1" descr="preencoded.png">    </p:cNvPr>
-          <p:cNvPicPr>
-            <a:picLocks noChangeAspect="1"/>
-          </p:cNvPicPr>
-          <p:nvPr/>
-        </p:nvPicPr>
-        <p:blipFill>
-          <a:blip r:embed="rId2"/>
-          <a:stretch>
-            <a:fillRect/>
-          </a:stretch>
-        </p:blipFill>
-        <p:spPr>
-          <a:xfrm>
-            <a:off x="777240" y="1673352"/>
-            <a:ext cx="274320" cy="274320"/>
-          </a:xfrm>
-          <a:prstGeom prst="rect">
-            <a:avLst/>
-          </a:prstGeom>
-        </p:spPr>
-      </p:pic>
-      <p:sp>
-        <p:nvSpPr>
-          <p:cNvPr id="8" name="Text 4"/>
-          <p:cNvSpPr/>
-          <p:nvPr/>
-        </p:nvSpPr>
-        <p:spPr>
-          <a:xfrm>
-            <a:off x="1325880" y="1490472"/>
-            <a:ext cx="3017520" cy="502920"/>
+      <p:sp>
+        <p:nvSpPr>
+          <p:cNvPr id="10" name="Text 7"/>
+          <p:cNvSpPr/>
+          <p:nvPr/>
+        </p:nvSpPr>
+        <p:spPr>
+          <a:xfrm>
+            <a:off x="3236976" y="2240280"/>
+            <a:ext cx="2670048" cy="731520"/>
           </a:xfrm>
           <a:prstGeom prst="rect">
             <a:avLst/>
@@ -2651,34 +2835,34 @@
           <a:bodyPr wrap="square" lIns="0" tIns="0" rIns="0" bIns="0" rtlCol="0" anchor="ctr"/>
           <a:lstStyle/>
           <a:p>
-            <a:pPr indent="0" marL="0">
-              <a:buNone/>
-            </a:pPr>
-            <a:r>
-              <a:rPr lang="en-US" sz="1350" b="1" dirty="0">
-                <a:solidFill>
-                  <a:srgbClr val="1E2D33"/>
-                </a:solidFill>
-                <a:latin typeface="Calibri" pitchFamily="34" charset="0"/>
-                <a:ea typeface="Calibri" pitchFamily="34" charset="-122"/>
-                <a:cs typeface="Calibri" pitchFamily="34" charset="-120"/>
-              </a:rPr>
-              <a:t>Des features adaptées au domaine</a:t>
-            </a:r>
-            <a:endParaRPr lang="en-US" sz="1350" dirty="0"/>
-          </a:p>
-        </p:txBody>
-      </p:sp>
-      <p:sp>
-        <p:nvSpPr>
-          <p:cNvPr id="9" name="Text 5"/>
-          <p:cNvSpPr/>
-          <p:nvPr/>
-        </p:nvSpPr>
-        <p:spPr>
-          <a:xfrm>
-            <a:off x="1325880" y="1929384"/>
-            <a:ext cx="2971800" cy="822960"/>
+            <a:pPr algn="ctr" indent="0" marL="0">
+              <a:buNone/>
+            </a:pPr>
+            <a:r>
+              <a:rPr lang="en-US" sz="4000" b="1" dirty="0">
+                <a:solidFill>
+                  <a:srgbClr val="0C7B8C"/>
+                </a:solidFill>
+                <a:latin typeface="Calibri" pitchFamily="34" charset="0"/>
+                <a:ea typeface="Calibri" pitchFamily="34" charset="-122"/>
+                <a:cs typeface="Calibri" pitchFamily="34" charset="-120"/>
+              </a:rPr>
+              <a:t>0,00125 €</a:t>
+            </a:r>
+            <a:endParaRPr lang="en-US" sz="4000" dirty="0"/>
+          </a:p>
+        </p:txBody>
+      </p:sp>
+      <p:sp>
+        <p:nvSpPr>
+          <p:cNvPr id="11" name="Text 8"/>
+          <p:cNvSpPr/>
+          <p:nvPr/>
+        </p:nvSpPr>
+        <p:spPr>
+          <a:xfrm>
+            <a:off x="3236976" y="2953512"/>
+            <a:ext cx="2670048" cy="640080"/>
           </a:xfrm>
           <a:prstGeom prst="rect">
             <a:avLst/>
@@ -2690,11 +2874,11 @@
           <a:bodyPr wrap="square" lIns="0" tIns="0" rIns="0" bIns="0" rtlCol="0" anchor="ctr"/>
           <a:lstStyle/>
           <a:p>
-            <a:pPr indent="0" marL="0">
-              <a:buNone/>
-            </a:pPr>
-            <a:r>
-              <a:rPr lang="en-US" sz="1080" dirty="0">
+            <a:pPr algn="ctr" indent="0" marL="0">
+              <a:buNone/>
+            </a:pPr>
+            <a:r>
+              <a:rPr lang="en-US" sz="1250" dirty="0">
                 <a:solidFill>
                   <a:srgbClr val="5B7179"/>
                 </a:solidFill>
@@ -2702,26 +2886,26 @@
                 <a:ea typeface="Calibri" pitchFamily="34" charset="-122"/>
                 <a:cs typeface="Calibri" pitchFamily="34" charset="-120"/>
               </a:rPr>
-              <a:t>Remplacer ImageNet par un encodeur auto-supervisé (SimCLR/DINO) entraîné sur les 4 M images non labellisées, ou un backbone médical. C'est le levier n°1 (ARI à 0,12 aujourd'hui).</a:t>
-            </a:r>
-            <a:endParaRPr lang="en-US" sz="1080" dirty="0"/>
-          </a:p>
-        </p:txBody>
-      </p:sp>
-      <p:sp>
-        <p:nvSpPr>
-          <p:cNvPr id="10" name="Shape 6"/>
-          <p:cNvSpPr/>
-          <p:nvPr/>
-        </p:nvSpPr>
-        <p:spPr>
-          <a:xfrm>
-            <a:off x="4663440" y="1325880"/>
-            <a:ext cx="4023360" cy="1481328"/>
+              <a:t>coût/image visé (5 000 € / 4 M)</a:t>
+            </a:r>
+            <a:endParaRPr lang="en-US" sz="1250" dirty="0"/>
+          </a:p>
+        </p:txBody>
+      </p:sp>
+      <p:sp>
+        <p:nvSpPr>
+          <p:cNvPr id="12" name="Shape 9"/>
+          <p:cNvSpPr/>
+          <p:nvPr/>
+        </p:nvSpPr>
+        <p:spPr>
+          <a:xfrm>
+            <a:off x="6016752" y="1828800"/>
+            <a:ext cx="2670048" cy="2103120"/>
           </a:xfrm>
           <a:prstGeom prst="roundRect">
             <a:avLst>
-              <a:gd name="adj" fmla="val 4938"/>
+              <a:gd name="adj" fmla="val 3478"/>
             </a:avLst>
           </a:prstGeom>
           <a:solidFill>
@@ -2739,65 +2923,14 @@
       </p:sp>
       <p:sp>
         <p:nvSpPr>
-          <p:cNvPr id="11" name="Shape 7"/>
-          <p:cNvSpPr/>
-          <p:nvPr/>
-        </p:nvSpPr>
-        <p:spPr>
-          <a:xfrm>
-            <a:off x="4864608" y="1554480"/>
-            <a:ext cx="512064" cy="512064"/>
-          </a:xfrm>
-          <a:prstGeom prst="ellipse">
-            <a:avLst/>
-          </a:prstGeom>
-          <a:solidFill>
-            <a:srgbClr val="0C7B8C"/>
-          </a:solidFill>
-          <a:ln/>
-          <a:effectLst>
-            <a:outerShdw sx="100000" sy="100000" kx="0" ky="0" algn="bl" rotWithShape="0" blurRad="88900" dist="38100" dir="5400000">
-              <a:srgbClr val="000000">
-                <a:alpha val="13000"/>
-              </a:srgbClr>
-            </a:outerShdw>
-          </a:effectLst>
-        </p:spPr>
-      </p:sp>
-      <p:pic>
-        <p:nvPicPr>
-          <p:cNvPr id="12" name="Image 2" descr="preencoded.png">    </p:cNvPr>
-          <p:cNvPicPr>
-            <a:picLocks noChangeAspect="1"/>
-          </p:cNvPicPr>
-          <p:nvPr/>
-        </p:nvPicPr>
-        <p:blipFill>
-          <a:blip r:embed="rId3"/>
-          <a:stretch>
-            <a:fillRect/>
-          </a:stretch>
-        </p:blipFill>
-        <p:spPr>
-          <a:xfrm>
-            <a:off x="4983480" y="1673352"/>
-            <a:ext cx="274320" cy="274320"/>
-          </a:xfrm>
-          <a:prstGeom prst="rect">
-            <a:avLst/>
-          </a:prstGeom>
-        </p:spPr>
-      </p:pic>
-      <p:sp>
-        <p:nvSpPr>
-          <p:cNvPr id="13" name="Text 8"/>
-          <p:cNvSpPr/>
-          <p:nvPr/>
-        </p:nvSpPr>
-        <p:spPr>
-          <a:xfrm>
-            <a:off x="5532120" y="1490472"/>
-            <a:ext cx="3017520" cy="502920"/>
+          <p:cNvPr id="13" name="Text 10"/>
+          <p:cNvSpPr/>
+          <p:nvPr/>
+        </p:nvSpPr>
+        <p:spPr>
+          <a:xfrm>
+            <a:off x="6016752" y="2240280"/>
+            <a:ext cx="2670048" cy="731520"/>
           </a:xfrm>
           <a:prstGeom prst="rect">
             <a:avLst/>
@@ -2809,50 +2942,89 @@
           <a:bodyPr wrap="square" lIns="0" tIns="0" rIns="0" bIns="0" rtlCol="0" anchor="ctr"/>
           <a:lstStyle/>
           <a:p>
+            <a:pPr algn="ctr" indent="0" marL="0">
+              <a:buNone/>
+            </a:pPr>
+            <a:r>
+              <a:rPr lang="en-US" sz="4000" b="1" dirty="0">
+                <a:solidFill>
+                  <a:srgbClr val="E4572E"/>
+                </a:solidFill>
+                <a:latin typeface="Calibri" pitchFamily="34" charset="0"/>
+                <a:ea typeface="Calibri" pitchFamily="34" charset="-122"/>
+                <a:cs typeface="Calibri" pitchFamily="34" charset="-120"/>
+              </a:rPr>
+              <a:t>× 160</a:t>
+            </a:r>
+            <a:endParaRPr lang="en-US" sz="4000" dirty="0"/>
+          </a:p>
+        </p:txBody>
+      </p:sp>
+      <p:sp>
+        <p:nvSpPr>
+          <p:cNvPr id="14" name="Text 11"/>
+          <p:cNvSpPr/>
+          <p:nvPr/>
+        </p:nvSpPr>
+        <p:spPr>
+          <a:xfrm>
+            <a:off x="6016752" y="2953512"/>
+            <a:ext cx="2670048" cy="640080"/>
+          </a:xfrm>
+          <a:prstGeom prst="rect">
+            <a:avLst/>
+          </a:prstGeom>
+          <a:noFill/>
+          <a:ln/>
+        </p:spPr>
+        <p:txBody>
+          <a:bodyPr wrap="square" lIns="0" tIns="0" rIns="0" bIns="0" rtlCol="0" anchor="ctr"/>
+          <a:lstStyle/>
+          <a:p>
+            <a:pPr algn="ctr" indent="0" marL="0">
+              <a:buNone/>
+            </a:pPr>
+            <a:r>
+              <a:rPr lang="en-US" sz="1250" dirty="0">
+                <a:solidFill>
+                  <a:srgbClr val="5B7179"/>
+                </a:solidFill>
+                <a:latin typeface="Calibri" pitchFamily="34" charset="0"/>
+                <a:ea typeface="Calibri" pitchFamily="34" charset="-122"/>
+                <a:cs typeface="Calibri" pitchFamily="34" charset="-120"/>
+              </a:rPr>
+              <a:t>réduction de coût par image exigée</a:t>
+            </a:r>
+            <a:endParaRPr lang="en-US" sz="1250" dirty="0"/>
+          </a:p>
+        </p:txBody>
+      </p:sp>
+      <p:sp>
+        <p:nvSpPr>
+          <p:cNvPr id="15" name="Text 12"/>
+          <p:cNvSpPr/>
+          <p:nvPr/>
+        </p:nvSpPr>
+        <p:spPr>
+          <a:xfrm>
+            <a:off x="457200" y="4114800"/>
+            <a:ext cx="8229600" cy="822960"/>
+          </a:xfrm>
+          <a:prstGeom prst="rect">
+            <a:avLst/>
+          </a:prstGeom>
+          <a:noFill/>
+          <a:ln/>
+        </p:spPr>
+        <p:txBody>
+          <a:bodyPr wrap="square" lIns="0" tIns="0" rIns="0" bIns="0" rtlCol="0" anchor="ctr"/>
+          <a:lstStyle/>
+          <a:p>
             <a:pPr indent="0" marL="0">
               <a:buNone/>
             </a:pPr>
             <a:r>
-              <a:rPr lang="en-US" sz="1350" b="1" dirty="0">
-                <a:solidFill>
-                  <a:srgbClr val="1E2D33"/>
-                </a:solidFill>
-                <a:latin typeface="Calibri" pitchFamily="34" charset="0"/>
-                <a:ea typeface="Calibri" pitchFamily="34" charset="-122"/>
-                <a:cs typeface="Calibri" pitchFamily="34" charset="-120"/>
-              </a:rPr>
-              <a:t>De l'active learning</a:t>
-            </a:r>
-            <a:endParaRPr lang="en-US" sz="1350" dirty="0"/>
-          </a:p>
-        </p:txBody>
-      </p:sp>
-      <p:sp>
-        <p:nvSpPr>
-          <p:cNvPr id="14" name="Text 9"/>
-          <p:cNvSpPr/>
-          <p:nvPr/>
-        </p:nvSpPr>
-        <p:spPr>
-          <a:xfrm>
-            <a:off x="5532120" y="1929384"/>
-            <a:ext cx="2971800" cy="822960"/>
-          </a:xfrm>
-          <a:prstGeom prst="rect">
-            <a:avLst/>
-          </a:prstGeom>
-          <a:noFill/>
-          <a:ln/>
-        </p:spPr>
-        <p:txBody>
-          <a:bodyPr wrap="square" lIns="0" tIns="0" rIns="0" bIns="0" rtlCol="0" anchor="ctr"/>
-          <a:lstStyle/>
-          <a:p>
-            <a:pPr indent="0" marL="0">
-              <a:buNone/>
-            </a:pPr>
-            <a:r>
-              <a:rPr lang="en-US" sz="1080" dirty="0">
+              <a:rPr lang="en-US" sz="1250" i="1" dirty="0">
                 <a:solidFill>
                   <a:srgbClr val="5B7179"/>
                 </a:solidFill>
@@ -2860,325 +3032,9 @@
                 <a:ea typeface="Calibri" pitchFamily="34" charset="-122"/>
                 <a:cs typeface="Calibri" pitchFamily="34" charset="-120"/>
               </a:rPr>
-              <a:t>Dépenser le budget d'annotation experte sur les images les plus incertaines plutôt qu'au hasard : maximiser la valeur de chaque label payé.</a:t>
-            </a:r>
-            <a:endParaRPr lang="en-US" sz="1080" dirty="0"/>
-          </a:p>
-        </p:txBody>
-      </p:sp>
-      <p:sp>
-        <p:nvSpPr>
-          <p:cNvPr id="15" name="Shape 10"/>
-          <p:cNvSpPr/>
-          <p:nvPr/>
-        </p:nvSpPr>
-        <p:spPr>
-          <a:xfrm>
-            <a:off x="457200" y="2926080"/>
-            <a:ext cx="4023360" cy="1481328"/>
-          </a:xfrm>
-          <a:prstGeom prst="roundRect">
-            <a:avLst>
-              <a:gd name="adj" fmla="val 4938"/>
-            </a:avLst>
-          </a:prstGeom>
-          <a:solidFill>
-            <a:srgbClr val="EFF6F7"/>
-          </a:solidFill>
-          <a:ln/>
-          <a:effectLst>
-            <a:outerShdw sx="100000" sy="100000" kx="0" ky="0" algn="bl" rotWithShape="0" blurRad="88900" dist="38100" dir="5400000">
-              <a:srgbClr val="000000">
-                <a:alpha val="13000"/>
-              </a:srgbClr>
-            </a:outerShdw>
-          </a:effectLst>
-        </p:spPr>
-      </p:sp>
-      <p:sp>
-        <p:nvSpPr>
-          <p:cNvPr id="16" name="Shape 11"/>
-          <p:cNvSpPr/>
-          <p:nvPr/>
-        </p:nvSpPr>
-        <p:spPr>
-          <a:xfrm>
-            <a:off x="658368" y="3154680"/>
-            <a:ext cx="512064" cy="512064"/>
-          </a:xfrm>
-          <a:prstGeom prst="ellipse">
-            <a:avLst/>
-          </a:prstGeom>
-          <a:solidFill>
-            <a:srgbClr val="0C7B8C"/>
-          </a:solidFill>
-          <a:ln/>
-          <a:effectLst>
-            <a:outerShdw sx="100000" sy="100000" kx="0" ky="0" algn="bl" rotWithShape="0" blurRad="88900" dist="38100" dir="5400000">
-              <a:srgbClr val="000000">
-                <a:alpha val="13000"/>
-              </a:srgbClr>
-            </a:outerShdw>
-          </a:effectLst>
-        </p:spPr>
-      </p:sp>
-      <p:pic>
-        <p:nvPicPr>
-          <p:cNvPr id="17" name="Image 3" descr="preencoded.png">    </p:cNvPr>
-          <p:cNvPicPr>
-            <a:picLocks noChangeAspect="1"/>
-          </p:cNvPicPr>
-          <p:nvPr/>
-        </p:nvPicPr>
-        <p:blipFill>
-          <a:blip r:embed="rId4"/>
-          <a:stretch>
-            <a:fillRect/>
-          </a:stretch>
-        </p:blipFill>
-        <p:spPr>
-          <a:xfrm>
-            <a:off x="777240" y="3273552"/>
-            <a:ext cx="274320" cy="274320"/>
-          </a:xfrm>
-          <a:prstGeom prst="rect">
-            <a:avLst/>
-          </a:prstGeom>
-        </p:spPr>
-      </p:pic>
-      <p:sp>
-        <p:nvSpPr>
-          <p:cNvPr id="18" name="Text 12"/>
-          <p:cNvSpPr/>
-          <p:nvPr/>
-        </p:nvSpPr>
-        <p:spPr>
-          <a:xfrm>
-            <a:off x="1325880" y="3090672"/>
-            <a:ext cx="3017520" cy="502920"/>
-          </a:xfrm>
-          <a:prstGeom prst="rect">
-            <a:avLst/>
-          </a:prstGeom>
-          <a:noFill/>
-          <a:ln/>
-        </p:spPr>
-        <p:txBody>
-          <a:bodyPr wrap="square" lIns="0" tIns="0" rIns="0" bIns="0" rtlCol="0" anchor="ctr"/>
-          <a:lstStyle/>
-          <a:p>
-            <a:pPr indent="0" marL="0">
-              <a:buNone/>
-            </a:pPr>
-            <a:r>
-              <a:rPr lang="en-US" sz="1350" b="1" dirty="0">
-                <a:solidFill>
-                  <a:srgbClr val="1E2D33"/>
-                </a:solidFill>
-                <a:latin typeface="Calibri" pitchFamily="34" charset="0"/>
-                <a:ea typeface="Calibri" pitchFamily="34" charset="-122"/>
-                <a:cs typeface="Calibri" pitchFamily="34" charset="-120"/>
-              </a:rPr>
-              <a:t>Un humain dans la boucle</a:t>
-            </a:r>
-            <a:endParaRPr lang="en-US" sz="1350" dirty="0"/>
-          </a:p>
-        </p:txBody>
-      </p:sp>
-      <p:sp>
-        <p:nvSpPr>
-          <p:cNvPr id="19" name="Text 13"/>
-          <p:cNvSpPr/>
-          <p:nvPr/>
-        </p:nvSpPr>
-        <p:spPr>
-          <a:xfrm>
-            <a:off x="1325880" y="3529584"/>
-            <a:ext cx="2971800" cy="822960"/>
-          </a:xfrm>
-          <a:prstGeom prst="rect">
-            <a:avLst/>
-          </a:prstGeom>
-          <a:noFill/>
-          <a:ln/>
-        </p:spPr>
-        <p:txBody>
-          <a:bodyPr wrap="square" lIns="0" tIns="0" rIns="0" bIns="0" rtlCol="0" anchor="ctr"/>
-          <a:lstStyle/>
-          <a:p>
-            <a:pPr indent="0" marL="0">
-              <a:buNone/>
-            </a:pPr>
-            <a:r>
-              <a:rPr lang="en-US" sz="1080" dirty="0">
-                <a:solidFill>
-                  <a:srgbClr val="5B7179"/>
-                </a:solidFill>
-                <a:latin typeface="Calibri" pitchFamily="34" charset="0"/>
-                <a:ea typeface="Calibri" pitchFamily="34" charset="-122"/>
-                <a:cs typeface="Calibri" pitchFamily="34" charset="-120"/>
-              </a:rPr>
-              <a:t>Revue experte des cas que le modèle flague comme « cancer » : on privilégie le rappel, l'humain filtre les fausses alertes.</a:t>
-            </a:r>
-            <a:endParaRPr lang="en-US" sz="1080" dirty="0"/>
-          </a:p>
-        </p:txBody>
-      </p:sp>
-      <p:sp>
-        <p:nvSpPr>
-          <p:cNvPr id="20" name="Shape 14"/>
-          <p:cNvSpPr/>
-          <p:nvPr/>
-        </p:nvSpPr>
-        <p:spPr>
-          <a:xfrm>
-            <a:off x="4663440" y="2926080"/>
-            <a:ext cx="4023360" cy="1481328"/>
-          </a:xfrm>
-          <a:prstGeom prst="roundRect">
-            <a:avLst>
-              <a:gd name="adj" fmla="val 4938"/>
-            </a:avLst>
-          </a:prstGeom>
-          <a:solidFill>
-            <a:srgbClr val="EFF6F7"/>
-          </a:solidFill>
-          <a:ln/>
-          <a:effectLst>
-            <a:outerShdw sx="100000" sy="100000" kx="0" ky="0" algn="bl" rotWithShape="0" blurRad="88900" dist="38100" dir="5400000">
-              <a:srgbClr val="000000">
-                <a:alpha val="13000"/>
-              </a:srgbClr>
-            </a:outerShdw>
-          </a:effectLst>
-        </p:spPr>
-      </p:sp>
-      <p:sp>
-        <p:nvSpPr>
-          <p:cNvPr id="21" name="Shape 15"/>
-          <p:cNvSpPr/>
-          <p:nvPr/>
-        </p:nvSpPr>
-        <p:spPr>
-          <a:xfrm>
-            <a:off x="4864608" y="3154680"/>
-            <a:ext cx="512064" cy="512064"/>
-          </a:xfrm>
-          <a:prstGeom prst="ellipse">
-            <a:avLst/>
-          </a:prstGeom>
-          <a:solidFill>
-            <a:srgbClr val="0C7B8C"/>
-          </a:solidFill>
-          <a:ln/>
-          <a:effectLst>
-            <a:outerShdw sx="100000" sy="100000" kx="0" ky="0" algn="bl" rotWithShape="0" blurRad="88900" dist="38100" dir="5400000">
-              <a:srgbClr val="000000">
-                <a:alpha val="13000"/>
-              </a:srgbClr>
-            </a:outerShdw>
-          </a:effectLst>
-        </p:spPr>
-      </p:sp>
-      <p:pic>
-        <p:nvPicPr>
-          <p:cNvPr id="22" name="Image 4" descr="preencoded.png">    </p:cNvPr>
-          <p:cNvPicPr>
-            <a:picLocks noChangeAspect="1"/>
-          </p:cNvPicPr>
-          <p:nvPr/>
-        </p:nvPicPr>
-        <p:blipFill>
-          <a:blip r:embed="rId5"/>
-          <a:stretch>
-            <a:fillRect/>
-          </a:stretch>
-        </p:blipFill>
-        <p:spPr>
-          <a:xfrm>
-            <a:off x="4983480" y="3273552"/>
-            <a:ext cx="274320" cy="274320"/>
-          </a:xfrm>
-          <a:prstGeom prst="rect">
-            <a:avLst/>
-          </a:prstGeom>
-        </p:spPr>
-      </p:pic>
-      <p:sp>
-        <p:nvSpPr>
-          <p:cNvPr id="23" name="Text 16"/>
-          <p:cNvSpPr/>
-          <p:nvPr/>
-        </p:nvSpPr>
-        <p:spPr>
-          <a:xfrm>
-            <a:off x="5532120" y="3090672"/>
-            <a:ext cx="3017520" cy="502920"/>
-          </a:xfrm>
-          <a:prstGeom prst="rect">
-            <a:avLst/>
-          </a:prstGeom>
-          <a:noFill/>
-          <a:ln/>
-        </p:spPr>
-        <p:txBody>
-          <a:bodyPr wrap="square" lIns="0" tIns="0" rIns="0" bIns="0" rtlCol="0" anchor="ctr"/>
-          <a:lstStyle/>
-          <a:p>
-            <a:pPr indent="0" marL="0">
-              <a:buNone/>
-            </a:pPr>
-            <a:r>
-              <a:rPr lang="en-US" sz="1350" b="1" dirty="0">
-                <a:solidFill>
-                  <a:srgbClr val="1E2D33"/>
-                </a:solidFill>
-                <a:latin typeface="Calibri" pitchFamily="34" charset="0"/>
-                <a:ea typeface="Calibri" pitchFamily="34" charset="-122"/>
-                <a:cs typeface="Calibri" pitchFamily="34" charset="-120"/>
-              </a:rPr>
-              <a:t>Infra GPU &amp; évaluation robuste</a:t>
-            </a:r>
-            <a:endParaRPr lang="en-US" sz="1350" dirty="0"/>
-          </a:p>
-        </p:txBody>
-      </p:sp>
-      <p:sp>
-        <p:nvSpPr>
-          <p:cNvPr id="24" name="Text 17"/>
-          <p:cNvSpPr/>
-          <p:nvPr/>
-        </p:nvSpPr>
-        <p:spPr>
-          <a:xfrm>
-            <a:off x="5532120" y="3529584"/>
-            <a:ext cx="2971800" cy="822960"/>
-          </a:xfrm>
-          <a:prstGeom prst="rect">
-            <a:avLst/>
-          </a:prstGeom>
-          <a:noFill/>
-          <a:ln/>
-        </p:spPr>
-        <p:txBody>
-          <a:bodyPr wrap="square" lIns="0" tIns="0" rIns="0" bIns="0" rtlCol="0" anchor="ctr"/>
-          <a:lstStyle/>
-          <a:p>
-            <a:pPr indent="0" marL="0">
-              <a:buNone/>
-            </a:pPr>
-            <a:r>
-              <a:rPr lang="en-US" sz="1080" dirty="0">
-                <a:solidFill>
-                  <a:srgbClr val="5B7179"/>
-                </a:solidFill>
-                <a:latin typeface="Calibri" pitchFamily="34" charset="0"/>
-                <a:ea typeface="Calibri" pitchFamily="34" charset="-122"/>
-                <a:cs typeface="Calibri" pitchFamily="34" charset="-120"/>
-              </a:rPr>
-              <a:t>GPU pour 4 M images, et un jeu de test conséquent (≫ 30) pour mesurer des gains fiables, pas du bruit.</a:t>
-            </a:r>
-            <a:endParaRPr lang="en-US" sz="1080" dirty="0"/>
+              <a:t>Le calcul pur de compute (inférence sur GPU) tient largement dans 5 000 €. La contrainte n'est donc pas le budget mais la QUALITÉ des labels produits : à 0,68 d'accuracy au clustering, propager tel quel à 4 M d'images amplifierait le bruit.</a:t>
+            </a:r>
+            <a:endParaRPr lang="en-US" sz="1250" dirty="0"/>
           </a:p>
         </p:txBody>
       </p:sp>
@@ -3193,6 +3049,760 @@
 <file path=ppt/slides/slide11.xml><?xml version="1.0" encoding="utf-8"?>
 <p:sld xmlns:a="http://schemas.openxmlformats.org/drawingml/2006/main" xmlns:r="http://schemas.openxmlformats.org/officeDocument/2006/relationships" xmlns:p="http://schemas.openxmlformats.org/presentationml/2006/main">
   <p:cSld name="Slide 11">
+    <p:bg>
+      <p:bgPr>
+        <a:solidFill>
+          <a:srgbClr val="FFFFFF"/>
+        </a:solidFill>
+      </p:bgPr>
+    </p:bg>
+    <p:spTree>
+      <p:nvGrpSpPr>
+        <p:cNvPr id="1" name=""/>
+        <p:cNvGrpSpPr/>
+        <p:nvPr/>
+      </p:nvGrpSpPr>
+      <p:grpSpPr>
+        <a:xfrm>
+          <a:off x="0" y="0"/>
+          <a:ext cx="0" cy="0"/>
+          <a:chOff x="0" y="0"/>
+          <a:chExt cx="0" cy="0"/>
+        </a:xfrm>
+      </p:grpSpPr>
+      <p:sp>
+        <p:nvSpPr>
+          <p:cNvPr id="2" name="Shape 0"/>
+          <p:cNvSpPr/>
+          <p:nvPr/>
+        </p:nvSpPr>
+        <p:spPr>
+          <a:xfrm>
+            <a:off x="457200" y="384048"/>
+            <a:ext cx="566928" cy="566928"/>
+          </a:xfrm>
+          <a:prstGeom prst="ellipse">
+            <a:avLst/>
+          </a:prstGeom>
+          <a:solidFill>
+            <a:srgbClr val="0C7B8C"/>
+          </a:solidFill>
+          <a:ln/>
+          <a:effectLst>
+            <a:outerShdw sx="100000" sy="100000" kx="0" ky="0" algn="bl" rotWithShape="0" blurRad="88900" dist="38100" dir="5400000">
+              <a:srgbClr val="000000">
+                <a:alpha val="13000"/>
+              </a:srgbClr>
+            </a:outerShdw>
+          </a:effectLst>
+        </p:spPr>
+      </p:sp>
+      <p:pic>
+        <p:nvPicPr>
+          <p:cNvPr id="3" name="Image 0" descr="preencoded.png">    </p:cNvPr>
+          <p:cNvPicPr>
+            <a:picLocks noChangeAspect="1"/>
+          </p:cNvPicPr>
+          <p:nvPr/>
+        </p:nvPicPr>
+        <p:blipFill>
+          <a:blip r:embed="rId1"/>
+          <a:stretch>
+            <a:fillRect/>
+          </a:stretch>
+        </p:blipFill>
+        <p:spPr>
+          <a:xfrm>
+            <a:off x="585216" y="512064"/>
+            <a:ext cx="310896" cy="310896"/>
+          </a:xfrm>
+          <a:prstGeom prst="rect">
+            <a:avLst/>
+          </a:prstGeom>
+        </p:spPr>
+      </p:pic>
+      <p:sp>
+        <p:nvSpPr>
+          <p:cNvPr id="4" name="Text 1"/>
+          <p:cNvSpPr/>
+          <p:nvPr/>
+        </p:nvSpPr>
+        <p:spPr>
+          <a:xfrm>
+            <a:off x="1170432" y="365760"/>
+            <a:ext cx="7498080" cy="603504"/>
+          </a:xfrm>
+          <a:prstGeom prst="rect">
+            <a:avLst/>
+          </a:prstGeom>
+          <a:noFill/>
+          <a:ln/>
+        </p:spPr>
+        <p:txBody>
+          <a:bodyPr wrap="square" lIns="0" tIns="0" rIns="0" bIns="0" rtlCol="0" anchor="ctr"/>
+          <a:lstStyle/>
+          <a:p>
+            <a:pPr indent="0" marL="0">
+              <a:buNone/>
+            </a:pPr>
+            <a:r>
+              <a:rPr lang="en-US" sz="2600" b="1" dirty="0">
+                <a:solidFill>
+                  <a:srgbClr val="1E2D33"/>
+                </a:solidFill>
+                <a:latin typeface="Calibri" pitchFamily="34" charset="0"/>
+                <a:ea typeface="Calibri" pitchFamily="34" charset="-122"/>
+                <a:cs typeface="Calibri" pitchFamily="34" charset="-120"/>
+              </a:rPr>
+              <a:t>Faisable — sous 4 conditions</a:t>
+            </a:r>
+            <a:endParaRPr lang="en-US" sz="2600" dirty="0"/>
+          </a:p>
+        </p:txBody>
+      </p:sp>
+      <p:sp>
+        <p:nvSpPr>
+          <p:cNvPr id="5" name="Shape 2"/>
+          <p:cNvSpPr/>
+          <p:nvPr/>
+        </p:nvSpPr>
+        <p:spPr>
+          <a:xfrm>
+            <a:off x="457200" y="1325880"/>
+            <a:ext cx="4023360" cy="1481328"/>
+          </a:xfrm>
+          <a:prstGeom prst="roundRect">
+            <a:avLst>
+              <a:gd name="adj" fmla="val 4938"/>
+            </a:avLst>
+          </a:prstGeom>
+          <a:solidFill>
+            <a:srgbClr val="EFF6F7"/>
+          </a:solidFill>
+          <a:ln/>
+          <a:effectLst>
+            <a:outerShdw sx="100000" sy="100000" kx="0" ky="0" algn="bl" rotWithShape="0" blurRad="88900" dist="38100" dir="5400000">
+              <a:srgbClr val="000000">
+                <a:alpha val="13000"/>
+              </a:srgbClr>
+            </a:outerShdw>
+          </a:effectLst>
+        </p:spPr>
+      </p:sp>
+      <p:sp>
+        <p:nvSpPr>
+          <p:cNvPr id="6" name="Shape 3"/>
+          <p:cNvSpPr/>
+          <p:nvPr/>
+        </p:nvSpPr>
+        <p:spPr>
+          <a:xfrm>
+            <a:off x="658368" y="1554480"/>
+            <a:ext cx="512064" cy="512064"/>
+          </a:xfrm>
+          <a:prstGeom prst="ellipse">
+            <a:avLst/>
+          </a:prstGeom>
+          <a:solidFill>
+            <a:srgbClr val="0C7B8C"/>
+          </a:solidFill>
+          <a:ln/>
+          <a:effectLst>
+            <a:outerShdw sx="100000" sy="100000" kx="0" ky="0" algn="bl" rotWithShape="0" blurRad="88900" dist="38100" dir="5400000">
+              <a:srgbClr val="000000">
+                <a:alpha val="13000"/>
+              </a:srgbClr>
+            </a:outerShdw>
+          </a:effectLst>
+        </p:spPr>
+      </p:sp>
+      <p:pic>
+        <p:nvPicPr>
+          <p:cNvPr id="7" name="Image 1" descr="preencoded.png">    </p:cNvPr>
+          <p:cNvPicPr>
+            <a:picLocks noChangeAspect="1"/>
+          </p:cNvPicPr>
+          <p:nvPr/>
+        </p:nvPicPr>
+        <p:blipFill>
+          <a:blip r:embed="rId2"/>
+          <a:stretch>
+            <a:fillRect/>
+          </a:stretch>
+        </p:blipFill>
+        <p:spPr>
+          <a:xfrm>
+            <a:off x="777240" y="1673352"/>
+            <a:ext cx="274320" cy="274320"/>
+          </a:xfrm>
+          <a:prstGeom prst="rect">
+            <a:avLst/>
+          </a:prstGeom>
+        </p:spPr>
+      </p:pic>
+      <p:sp>
+        <p:nvSpPr>
+          <p:cNvPr id="8" name="Text 4"/>
+          <p:cNvSpPr/>
+          <p:nvPr/>
+        </p:nvSpPr>
+        <p:spPr>
+          <a:xfrm>
+            <a:off x="1325880" y="1490472"/>
+            <a:ext cx="3017520" cy="502920"/>
+          </a:xfrm>
+          <a:prstGeom prst="rect">
+            <a:avLst/>
+          </a:prstGeom>
+          <a:noFill/>
+          <a:ln/>
+        </p:spPr>
+        <p:txBody>
+          <a:bodyPr wrap="square" lIns="0" tIns="0" rIns="0" bIns="0" rtlCol="0" anchor="ctr"/>
+          <a:lstStyle/>
+          <a:p>
+            <a:pPr indent="0" marL="0">
+              <a:buNone/>
+            </a:pPr>
+            <a:r>
+              <a:rPr lang="en-US" sz="1350" b="1" dirty="0">
+                <a:solidFill>
+                  <a:srgbClr val="1E2D33"/>
+                </a:solidFill>
+                <a:latin typeface="Calibri" pitchFamily="34" charset="0"/>
+                <a:ea typeface="Calibri" pitchFamily="34" charset="-122"/>
+                <a:cs typeface="Calibri" pitchFamily="34" charset="-120"/>
+              </a:rPr>
+              <a:t>Des features adaptées au domaine</a:t>
+            </a:r>
+            <a:endParaRPr lang="en-US" sz="1350" dirty="0"/>
+          </a:p>
+        </p:txBody>
+      </p:sp>
+      <p:sp>
+        <p:nvSpPr>
+          <p:cNvPr id="9" name="Text 5"/>
+          <p:cNvSpPr/>
+          <p:nvPr/>
+        </p:nvSpPr>
+        <p:spPr>
+          <a:xfrm>
+            <a:off x="1325880" y="1929384"/>
+            <a:ext cx="2971800" cy="822960"/>
+          </a:xfrm>
+          <a:prstGeom prst="rect">
+            <a:avLst/>
+          </a:prstGeom>
+          <a:noFill/>
+          <a:ln/>
+        </p:spPr>
+        <p:txBody>
+          <a:bodyPr wrap="square" lIns="0" tIns="0" rIns="0" bIns="0" rtlCol="0" anchor="ctr"/>
+          <a:lstStyle/>
+          <a:p>
+            <a:pPr indent="0" marL="0">
+              <a:buNone/>
+            </a:pPr>
+            <a:r>
+              <a:rPr lang="en-US" sz="1080" dirty="0">
+                <a:solidFill>
+                  <a:srgbClr val="5B7179"/>
+                </a:solidFill>
+                <a:latin typeface="Calibri" pitchFamily="34" charset="0"/>
+                <a:ea typeface="Calibri" pitchFamily="34" charset="-122"/>
+                <a:cs typeface="Calibri" pitchFamily="34" charset="-120"/>
+              </a:rPr>
+              <a:t>Remplacer ImageNet par un encodeur auto-supervisé (SimCLR/DINO) entraîné sur les 4 M images non labellisées, ou un backbone médical. C'est le levier n°1 (ARI à 0,12 aujourd'hui).</a:t>
+            </a:r>
+            <a:endParaRPr lang="en-US" sz="1080" dirty="0"/>
+          </a:p>
+        </p:txBody>
+      </p:sp>
+      <p:sp>
+        <p:nvSpPr>
+          <p:cNvPr id="10" name="Shape 6"/>
+          <p:cNvSpPr/>
+          <p:nvPr/>
+        </p:nvSpPr>
+        <p:spPr>
+          <a:xfrm>
+            <a:off x="4663440" y="1325880"/>
+            <a:ext cx="4023360" cy="1481328"/>
+          </a:xfrm>
+          <a:prstGeom prst="roundRect">
+            <a:avLst>
+              <a:gd name="adj" fmla="val 4938"/>
+            </a:avLst>
+          </a:prstGeom>
+          <a:solidFill>
+            <a:srgbClr val="EFF6F7"/>
+          </a:solidFill>
+          <a:ln/>
+          <a:effectLst>
+            <a:outerShdw sx="100000" sy="100000" kx="0" ky="0" algn="bl" rotWithShape="0" blurRad="88900" dist="38100" dir="5400000">
+              <a:srgbClr val="000000">
+                <a:alpha val="13000"/>
+              </a:srgbClr>
+            </a:outerShdw>
+          </a:effectLst>
+        </p:spPr>
+      </p:sp>
+      <p:sp>
+        <p:nvSpPr>
+          <p:cNvPr id="11" name="Shape 7"/>
+          <p:cNvSpPr/>
+          <p:nvPr/>
+        </p:nvSpPr>
+        <p:spPr>
+          <a:xfrm>
+            <a:off x="4864608" y="1554480"/>
+            <a:ext cx="512064" cy="512064"/>
+          </a:xfrm>
+          <a:prstGeom prst="ellipse">
+            <a:avLst/>
+          </a:prstGeom>
+          <a:solidFill>
+            <a:srgbClr val="0C7B8C"/>
+          </a:solidFill>
+          <a:ln/>
+          <a:effectLst>
+            <a:outerShdw sx="100000" sy="100000" kx="0" ky="0" algn="bl" rotWithShape="0" blurRad="88900" dist="38100" dir="5400000">
+              <a:srgbClr val="000000">
+                <a:alpha val="13000"/>
+              </a:srgbClr>
+            </a:outerShdw>
+          </a:effectLst>
+        </p:spPr>
+      </p:sp>
+      <p:pic>
+        <p:nvPicPr>
+          <p:cNvPr id="12" name="Image 2" descr="preencoded.png">    </p:cNvPr>
+          <p:cNvPicPr>
+            <a:picLocks noChangeAspect="1"/>
+          </p:cNvPicPr>
+          <p:nvPr/>
+        </p:nvPicPr>
+        <p:blipFill>
+          <a:blip r:embed="rId3"/>
+          <a:stretch>
+            <a:fillRect/>
+          </a:stretch>
+        </p:blipFill>
+        <p:spPr>
+          <a:xfrm>
+            <a:off x="4983480" y="1673352"/>
+            <a:ext cx="274320" cy="274320"/>
+          </a:xfrm>
+          <a:prstGeom prst="rect">
+            <a:avLst/>
+          </a:prstGeom>
+        </p:spPr>
+      </p:pic>
+      <p:sp>
+        <p:nvSpPr>
+          <p:cNvPr id="13" name="Text 8"/>
+          <p:cNvSpPr/>
+          <p:nvPr/>
+        </p:nvSpPr>
+        <p:spPr>
+          <a:xfrm>
+            <a:off x="5532120" y="1490472"/>
+            <a:ext cx="3017520" cy="502920"/>
+          </a:xfrm>
+          <a:prstGeom prst="rect">
+            <a:avLst/>
+          </a:prstGeom>
+          <a:noFill/>
+          <a:ln/>
+        </p:spPr>
+        <p:txBody>
+          <a:bodyPr wrap="square" lIns="0" tIns="0" rIns="0" bIns="0" rtlCol="0" anchor="ctr"/>
+          <a:lstStyle/>
+          <a:p>
+            <a:pPr indent="0" marL="0">
+              <a:buNone/>
+            </a:pPr>
+            <a:r>
+              <a:rPr lang="en-US" sz="1350" b="1" dirty="0">
+                <a:solidFill>
+                  <a:srgbClr val="1E2D33"/>
+                </a:solidFill>
+                <a:latin typeface="Calibri" pitchFamily="34" charset="0"/>
+                <a:ea typeface="Calibri" pitchFamily="34" charset="-122"/>
+                <a:cs typeface="Calibri" pitchFamily="34" charset="-120"/>
+              </a:rPr>
+              <a:t>De l'active learning</a:t>
+            </a:r>
+            <a:endParaRPr lang="en-US" sz="1350" dirty="0"/>
+          </a:p>
+        </p:txBody>
+      </p:sp>
+      <p:sp>
+        <p:nvSpPr>
+          <p:cNvPr id="14" name="Text 9"/>
+          <p:cNvSpPr/>
+          <p:nvPr/>
+        </p:nvSpPr>
+        <p:spPr>
+          <a:xfrm>
+            <a:off x="5532120" y="1929384"/>
+            <a:ext cx="2971800" cy="822960"/>
+          </a:xfrm>
+          <a:prstGeom prst="rect">
+            <a:avLst/>
+          </a:prstGeom>
+          <a:noFill/>
+          <a:ln/>
+        </p:spPr>
+        <p:txBody>
+          <a:bodyPr wrap="square" lIns="0" tIns="0" rIns="0" bIns="0" rtlCol="0" anchor="ctr"/>
+          <a:lstStyle/>
+          <a:p>
+            <a:pPr indent="0" marL="0">
+              <a:buNone/>
+            </a:pPr>
+            <a:r>
+              <a:rPr lang="en-US" sz="1080" dirty="0">
+                <a:solidFill>
+                  <a:srgbClr val="5B7179"/>
+                </a:solidFill>
+                <a:latin typeface="Calibri" pitchFamily="34" charset="0"/>
+                <a:ea typeface="Calibri" pitchFamily="34" charset="-122"/>
+                <a:cs typeface="Calibri" pitchFamily="34" charset="-120"/>
+              </a:rPr>
+              <a:t>Dépenser le budget d'annotation experte sur les images les plus incertaines plutôt qu'au hasard : maximiser la valeur de chaque label payé.</a:t>
+            </a:r>
+            <a:endParaRPr lang="en-US" sz="1080" dirty="0"/>
+          </a:p>
+        </p:txBody>
+      </p:sp>
+      <p:sp>
+        <p:nvSpPr>
+          <p:cNvPr id="15" name="Shape 10"/>
+          <p:cNvSpPr/>
+          <p:nvPr/>
+        </p:nvSpPr>
+        <p:spPr>
+          <a:xfrm>
+            <a:off x="457200" y="2926080"/>
+            <a:ext cx="4023360" cy="1481328"/>
+          </a:xfrm>
+          <a:prstGeom prst="roundRect">
+            <a:avLst>
+              <a:gd name="adj" fmla="val 4938"/>
+            </a:avLst>
+          </a:prstGeom>
+          <a:solidFill>
+            <a:srgbClr val="EFF6F7"/>
+          </a:solidFill>
+          <a:ln/>
+          <a:effectLst>
+            <a:outerShdw sx="100000" sy="100000" kx="0" ky="0" algn="bl" rotWithShape="0" blurRad="88900" dist="38100" dir="5400000">
+              <a:srgbClr val="000000">
+                <a:alpha val="13000"/>
+              </a:srgbClr>
+            </a:outerShdw>
+          </a:effectLst>
+        </p:spPr>
+      </p:sp>
+      <p:sp>
+        <p:nvSpPr>
+          <p:cNvPr id="16" name="Shape 11"/>
+          <p:cNvSpPr/>
+          <p:nvPr/>
+        </p:nvSpPr>
+        <p:spPr>
+          <a:xfrm>
+            <a:off x="658368" y="3154680"/>
+            <a:ext cx="512064" cy="512064"/>
+          </a:xfrm>
+          <a:prstGeom prst="ellipse">
+            <a:avLst/>
+          </a:prstGeom>
+          <a:solidFill>
+            <a:srgbClr val="0C7B8C"/>
+          </a:solidFill>
+          <a:ln/>
+          <a:effectLst>
+            <a:outerShdw sx="100000" sy="100000" kx="0" ky="0" algn="bl" rotWithShape="0" blurRad="88900" dist="38100" dir="5400000">
+              <a:srgbClr val="000000">
+                <a:alpha val="13000"/>
+              </a:srgbClr>
+            </a:outerShdw>
+          </a:effectLst>
+        </p:spPr>
+      </p:sp>
+      <p:pic>
+        <p:nvPicPr>
+          <p:cNvPr id="17" name="Image 3" descr="preencoded.png">    </p:cNvPr>
+          <p:cNvPicPr>
+            <a:picLocks noChangeAspect="1"/>
+          </p:cNvPicPr>
+          <p:nvPr/>
+        </p:nvPicPr>
+        <p:blipFill>
+          <a:blip r:embed="rId4"/>
+          <a:stretch>
+            <a:fillRect/>
+          </a:stretch>
+        </p:blipFill>
+        <p:spPr>
+          <a:xfrm>
+            <a:off x="777240" y="3273552"/>
+            <a:ext cx="274320" cy="274320"/>
+          </a:xfrm>
+          <a:prstGeom prst="rect">
+            <a:avLst/>
+          </a:prstGeom>
+        </p:spPr>
+      </p:pic>
+      <p:sp>
+        <p:nvSpPr>
+          <p:cNvPr id="18" name="Text 12"/>
+          <p:cNvSpPr/>
+          <p:nvPr/>
+        </p:nvSpPr>
+        <p:spPr>
+          <a:xfrm>
+            <a:off x="1325880" y="3090672"/>
+            <a:ext cx="3017520" cy="502920"/>
+          </a:xfrm>
+          <a:prstGeom prst="rect">
+            <a:avLst/>
+          </a:prstGeom>
+          <a:noFill/>
+          <a:ln/>
+        </p:spPr>
+        <p:txBody>
+          <a:bodyPr wrap="square" lIns="0" tIns="0" rIns="0" bIns="0" rtlCol="0" anchor="ctr"/>
+          <a:lstStyle/>
+          <a:p>
+            <a:pPr indent="0" marL="0">
+              <a:buNone/>
+            </a:pPr>
+            <a:r>
+              <a:rPr lang="en-US" sz="1350" b="1" dirty="0">
+                <a:solidFill>
+                  <a:srgbClr val="1E2D33"/>
+                </a:solidFill>
+                <a:latin typeface="Calibri" pitchFamily="34" charset="0"/>
+                <a:ea typeface="Calibri" pitchFamily="34" charset="-122"/>
+                <a:cs typeface="Calibri" pitchFamily="34" charset="-120"/>
+              </a:rPr>
+              <a:t>Un humain dans la boucle</a:t>
+            </a:r>
+            <a:endParaRPr lang="en-US" sz="1350" dirty="0"/>
+          </a:p>
+        </p:txBody>
+      </p:sp>
+      <p:sp>
+        <p:nvSpPr>
+          <p:cNvPr id="19" name="Text 13"/>
+          <p:cNvSpPr/>
+          <p:nvPr/>
+        </p:nvSpPr>
+        <p:spPr>
+          <a:xfrm>
+            <a:off x="1325880" y="3529584"/>
+            <a:ext cx="2971800" cy="822960"/>
+          </a:xfrm>
+          <a:prstGeom prst="rect">
+            <a:avLst/>
+          </a:prstGeom>
+          <a:noFill/>
+          <a:ln/>
+        </p:spPr>
+        <p:txBody>
+          <a:bodyPr wrap="square" lIns="0" tIns="0" rIns="0" bIns="0" rtlCol="0" anchor="ctr"/>
+          <a:lstStyle/>
+          <a:p>
+            <a:pPr indent="0" marL="0">
+              <a:buNone/>
+            </a:pPr>
+            <a:r>
+              <a:rPr lang="en-US" sz="1080" dirty="0">
+                <a:solidFill>
+                  <a:srgbClr val="5B7179"/>
+                </a:solidFill>
+                <a:latin typeface="Calibri" pitchFamily="34" charset="0"/>
+                <a:ea typeface="Calibri" pitchFamily="34" charset="-122"/>
+                <a:cs typeface="Calibri" pitchFamily="34" charset="-120"/>
+              </a:rPr>
+              <a:t>Revue experte des cas que le modèle flague comme « cancer » : on privilégie le rappel, l'humain filtre les fausses alertes.</a:t>
+            </a:r>
+            <a:endParaRPr lang="en-US" sz="1080" dirty="0"/>
+          </a:p>
+        </p:txBody>
+      </p:sp>
+      <p:sp>
+        <p:nvSpPr>
+          <p:cNvPr id="20" name="Shape 14"/>
+          <p:cNvSpPr/>
+          <p:nvPr/>
+        </p:nvSpPr>
+        <p:spPr>
+          <a:xfrm>
+            <a:off x="4663440" y="2926080"/>
+            <a:ext cx="4023360" cy="1481328"/>
+          </a:xfrm>
+          <a:prstGeom prst="roundRect">
+            <a:avLst>
+              <a:gd name="adj" fmla="val 4938"/>
+            </a:avLst>
+          </a:prstGeom>
+          <a:solidFill>
+            <a:srgbClr val="EFF6F7"/>
+          </a:solidFill>
+          <a:ln/>
+          <a:effectLst>
+            <a:outerShdw sx="100000" sy="100000" kx="0" ky="0" algn="bl" rotWithShape="0" blurRad="88900" dist="38100" dir="5400000">
+              <a:srgbClr val="000000">
+                <a:alpha val="13000"/>
+              </a:srgbClr>
+            </a:outerShdw>
+          </a:effectLst>
+        </p:spPr>
+      </p:sp>
+      <p:sp>
+        <p:nvSpPr>
+          <p:cNvPr id="21" name="Shape 15"/>
+          <p:cNvSpPr/>
+          <p:nvPr/>
+        </p:nvSpPr>
+        <p:spPr>
+          <a:xfrm>
+            <a:off x="4864608" y="3154680"/>
+            <a:ext cx="512064" cy="512064"/>
+          </a:xfrm>
+          <a:prstGeom prst="ellipse">
+            <a:avLst/>
+          </a:prstGeom>
+          <a:solidFill>
+            <a:srgbClr val="0C7B8C"/>
+          </a:solidFill>
+          <a:ln/>
+          <a:effectLst>
+            <a:outerShdw sx="100000" sy="100000" kx="0" ky="0" algn="bl" rotWithShape="0" blurRad="88900" dist="38100" dir="5400000">
+              <a:srgbClr val="000000">
+                <a:alpha val="13000"/>
+              </a:srgbClr>
+            </a:outerShdw>
+          </a:effectLst>
+        </p:spPr>
+      </p:sp>
+      <p:pic>
+        <p:nvPicPr>
+          <p:cNvPr id="22" name="Image 4" descr="preencoded.png">    </p:cNvPr>
+          <p:cNvPicPr>
+            <a:picLocks noChangeAspect="1"/>
+          </p:cNvPicPr>
+          <p:nvPr/>
+        </p:nvPicPr>
+        <p:blipFill>
+          <a:blip r:embed="rId5"/>
+          <a:stretch>
+            <a:fillRect/>
+          </a:stretch>
+        </p:blipFill>
+        <p:spPr>
+          <a:xfrm>
+            <a:off x="4983480" y="3273552"/>
+            <a:ext cx="274320" cy="274320"/>
+          </a:xfrm>
+          <a:prstGeom prst="rect">
+            <a:avLst/>
+          </a:prstGeom>
+        </p:spPr>
+      </p:pic>
+      <p:sp>
+        <p:nvSpPr>
+          <p:cNvPr id="23" name="Text 16"/>
+          <p:cNvSpPr/>
+          <p:nvPr/>
+        </p:nvSpPr>
+        <p:spPr>
+          <a:xfrm>
+            <a:off x="5532120" y="3090672"/>
+            <a:ext cx="3017520" cy="502920"/>
+          </a:xfrm>
+          <a:prstGeom prst="rect">
+            <a:avLst/>
+          </a:prstGeom>
+          <a:noFill/>
+          <a:ln/>
+        </p:spPr>
+        <p:txBody>
+          <a:bodyPr wrap="square" lIns="0" tIns="0" rIns="0" bIns="0" rtlCol="0" anchor="ctr"/>
+          <a:lstStyle/>
+          <a:p>
+            <a:pPr indent="0" marL="0">
+              <a:buNone/>
+            </a:pPr>
+            <a:r>
+              <a:rPr lang="en-US" sz="1350" b="1" dirty="0">
+                <a:solidFill>
+                  <a:srgbClr val="1E2D33"/>
+                </a:solidFill>
+                <a:latin typeface="Calibri" pitchFamily="34" charset="0"/>
+                <a:ea typeface="Calibri" pitchFamily="34" charset="-122"/>
+                <a:cs typeface="Calibri" pitchFamily="34" charset="-120"/>
+              </a:rPr>
+              <a:t>Infra GPU &amp; évaluation robuste</a:t>
+            </a:r>
+            <a:endParaRPr lang="en-US" sz="1350" dirty="0"/>
+          </a:p>
+        </p:txBody>
+      </p:sp>
+      <p:sp>
+        <p:nvSpPr>
+          <p:cNvPr id="24" name="Text 17"/>
+          <p:cNvSpPr/>
+          <p:nvPr/>
+        </p:nvSpPr>
+        <p:spPr>
+          <a:xfrm>
+            <a:off x="5532120" y="3529584"/>
+            <a:ext cx="2971800" cy="822960"/>
+          </a:xfrm>
+          <a:prstGeom prst="rect">
+            <a:avLst/>
+          </a:prstGeom>
+          <a:noFill/>
+          <a:ln/>
+        </p:spPr>
+        <p:txBody>
+          <a:bodyPr wrap="square" lIns="0" tIns="0" rIns="0" bIns="0" rtlCol="0" anchor="ctr"/>
+          <a:lstStyle/>
+          <a:p>
+            <a:pPr indent="0" marL="0">
+              <a:buNone/>
+            </a:pPr>
+            <a:r>
+              <a:rPr lang="en-US" sz="1080" dirty="0">
+                <a:solidFill>
+                  <a:srgbClr val="5B7179"/>
+                </a:solidFill>
+                <a:latin typeface="Calibri" pitchFamily="34" charset="0"/>
+                <a:ea typeface="Calibri" pitchFamily="34" charset="-122"/>
+                <a:cs typeface="Calibri" pitchFamily="34" charset="-120"/>
+              </a:rPr>
+              <a:t>GPU pour 4 M images, et un jeu de test conséquent (≫ 30) pour mesurer des gains fiables, pas du bruit.</a:t>
+            </a:r>
+            <a:endParaRPr lang="en-US" sz="1080" dirty="0"/>
+          </a:p>
+        </p:txBody>
+      </p:sp>
+    </p:spTree>
+  </p:cSld>
+  <p:clrMapOvr>
+    <a:masterClrMapping/>
+  </p:clrMapOvr>
+</p:sld>
+</file>
+
+<file path=ppt/slides/slide12.xml><?xml version="1.0" encoding="utf-8"?>
+<p:sld xmlns:a="http://schemas.openxmlformats.org/drawingml/2006/main" xmlns:r="http://schemas.openxmlformats.org/officeDocument/2006/relationships" xmlns:p="http://schemas.openxmlformats.org/presentationml/2006/main">
+  <p:cSld name="Slide 12">
     <p:bg>
       <p:bgPr>
         <a:solidFill>
@@ -6432,7 +7042,7 @@
                 <a:ea typeface="Calibri" pitchFamily="34" charset="-122"/>
                 <a:cs typeface="Calibri" pitchFamily="34" charset="-120"/>
               </a:rPr>
-              <a:t>F1 ≈ 0,85 et accuracy ≈ 0,87 sur ce test ; jusqu'à rappel 0,87 / F1 0,91 sur 5 découpages. Loin devant les deux CNN.</a:t>
+              <a:t>Sur 5 découpages : rappel 0,87 · F1 0,91 · AUC 0,95. Loin devant les deux CNN appris de zéro.</a:t>
             </a:r>
             <a:endParaRPr lang="en-US" sz="1150" dirty="0"/>
           </a:p>
@@ -6554,7 +7164,7 @@
                 <a:ea typeface="Calibri" pitchFamily="34" charset="-122"/>
                 <a:cs typeface="Calibri" pitchFamily="34" charset="-120"/>
               </a:rPr>
-              <a:t>Ce que révèle la comparaison</a:t>
+              <a:t>Robustesse &amp; validation</a:t>
             </a:r>
             <a:endParaRPr lang="en-US" sz="2600" dirty="0"/>
           </a:p>
@@ -6569,15 +7179,15 @@
         <p:spPr>
           <a:xfrm>
             <a:off x="457200" y="1325880"/>
-            <a:ext cx="8229600" cy="987552"/>
+            <a:ext cx="4023360" cy="1481328"/>
           </a:xfrm>
           <a:prstGeom prst="roundRect">
             <a:avLst>
-              <a:gd name="adj" fmla="val 7407"/>
+              <a:gd name="adj" fmla="val 4938"/>
             </a:avLst>
           </a:prstGeom>
           <a:solidFill>
-            <a:srgbClr val="FFFFFF"/>
+            <a:srgbClr val="EFF6F7"/>
           </a:solidFill>
           <a:ln/>
           <a:effectLst>
@@ -6597,14 +7207,14 @@
         </p:nvSpPr>
         <p:spPr>
           <a:xfrm>
-            <a:off x="658368" y="1563624"/>
+            <a:off x="658368" y="1554480"/>
             <a:ext cx="512064" cy="512064"/>
           </a:xfrm>
           <a:prstGeom prst="ellipse">
             <a:avLst/>
           </a:prstGeom>
           <a:solidFill>
-            <a:srgbClr val="E4572E"/>
+            <a:srgbClr val="0C7B8C"/>
           </a:solidFill>
           <a:ln/>
           <a:effectLst>
@@ -6632,7 +7242,7 @@
         </p:blipFill>
         <p:spPr>
           <a:xfrm>
-            <a:off x="777240" y="1682496"/>
+            <a:off x="777240" y="1673352"/>
             <a:ext cx="274320" cy="274320"/>
           </a:xfrm>
           <a:prstGeom prst="rect">
@@ -6648,8 +7258,8 @@
         </p:nvSpPr>
         <p:spPr>
           <a:xfrm>
-            <a:off x="1371600" y="1453896"/>
-            <a:ext cx="7132320" cy="365760"/>
+            <a:off x="1325880" y="1490472"/>
+            <a:ext cx="3017520" cy="457200"/>
           </a:xfrm>
           <a:prstGeom prst="rect">
             <a:avLst/>
@@ -6665,7 +7275,7 @@
               <a:buNone/>
             </a:pPr>
             <a:r>
-              <a:rPr lang="en-US" sz="1400" b="1" dirty="0">
+              <a:rPr lang="en-US" sz="1350" b="1" dirty="0">
                 <a:solidFill>
                   <a:srgbClr val="1E2D33"/>
                 </a:solidFill>
@@ -6673,9 +7283,9 @@
                 <a:ea typeface="Calibri" pitchFamily="34" charset="-122"/>
                 <a:cs typeface="Calibri" pitchFamily="34" charset="-120"/>
               </a:rPr>
-              <a:t>Les CNN appris de zéro plafonnent</a:t>
-            </a:r>
-            <a:endParaRPr lang="en-US" sz="1400" dirty="0"/>
+              <a:t>Test sans fuite</a:t>
+            </a:r>
+            <a:endParaRPr lang="en-US" sz="1350" dirty="0"/>
           </a:p>
         </p:txBody>
       </p:sp>
@@ -6687,8 +7297,8 @@
         </p:nvSpPr>
         <p:spPr>
           <a:xfrm>
-            <a:off x="1371600" y="1801368"/>
-            <a:ext cx="7178040" cy="457200"/>
+            <a:off x="1325880" y="1892808"/>
+            <a:ext cx="2971800" cy="841248"/>
           </a:xfrm>
           <a:prstGeom prst="rect">
             <a:avLst/>
@@ -6704,7 +7314,7 @@
               <a:buNone/>
             </a:pPr>
             <a:r>
-              <a:rPr lang="en-US" sz="1150" dirty="0">
+              <a:rPr lang="en-US" sz="1080" dirty="0">
                 <a:solidFill>
                   <a:srgbClr val="5B7179"/>
                 </a:solidFill>
@@ -6712,9 +7322,9 @@
                 <a:ea typeface="Calibri" pitchFamily="34" charset="-122"/>
                 <a:cs typeface="Calibri" pitchFamily="34" charset="-120"/>
               </a:rPr>
-              <a:t>Avec 70 (ou 1 406 bruitées) images, le CNN apprend mal ses propres features : supervisé et clustering-semi restent à égalité (F1 ≈ 0,72).</a:t>
-            </a:r>
-            <a:endParaRPr lang="en-US" sz="1150" dirty="0"/>
+              <a:t>Évaluation sur 30 IRM jamais vues ; séparation test / entraînement vérifiée (0 chevauchement).</a:t>
+            </a:r>
+            <a:endParaRPr lang="en-US" sz="1080" dirty="0"/>
           </a:p>
         </p:txBody>
       </p:sp>
@@ -6726,16 +7336,16 @@
         </p:nvSpPr>
         <p:spPr>
           <a:xfrm>
-            <a:off x="457200" y="2423160"/>
-            <a:ext cx="8229600" cy="987552"/>
+            <a:off x="4663440" y="1325880"/>
+            <a:ext cx="4023360" cy="1481328"/>
           </a:xfrm>
           <a:prstGeom prst="roundRect">
             <a:avLst>
-              <a:gd name="adj" fmla="val 7407"/>
+              <a:gd name="adj" fmla="val 4938"/>
             </a:avLst>
           </a:prstGeom>
           <a:solidFill>
-            <a:srgbClr val="FFFFFF"/>
+            <a:srgbClr val="EFF6F7"/>
           </a:solidFill>
           <a:ln/>
           <a:effectLst>
@@ -6755,14 +7365,14 @@
         </p:nvSpPr>
         <p:spPr>
           <a:xfrm>
-            <a:off x="658368" y="2660904"/>
+            <a:off x="4864608" y="1554480"/>
             <a:ext cx="512064" cy="512064"/>
           </a:xfrm>
           <a:prstGeom prst="ellipse">
             <a:avLst/>
           </a:prstGeom>
           <a:solidFill>
-            <a:srgbClr val="0C7B8C"/>
+            <a:srgbClr val="12B5A5"/>
           </a:solidFill>
           <a:ln/>
           <a:effectLst>
@@ -6790,7 +7400,7 @@
         </p:blipFill>
         <p:spPr>
           <a:xfrm>
-            <a:off x="777240" y="2779776"/>
+            <a:off x="4983480" y="1673352"/>
             <a:ext cx="274320" cy="274320"/>
           </a:xfrm>
           <a:prstGeom prst="rect">
@@ -6806,8 +7416,8 @@
         </p:nvSpPr>
         <p:spPr>
           <a:xfrm>
-            <a:off x="1371600" y="2551176"/>
-            <a:ext cx="7132320" cy="365760"/>
+            <a:off x="5532120" y="1490472"/>
+            <a:ext cx="3017520" cy="457200"/>
           </a:xfrm>
           <a:prstGeom prst="rect">
             <a:avLst/>
@@ -6823,7 +7433,7 @@
               <a:buNone/>
             </a:pPr>
             <a:r>
-              <a:rPr lang="en-US" sz="1400" b="1" dirty="0">
+              <a:rPr lang="en-US" sz="1350" b="1" dirty="0">
                 <a:solidFill>
                   <a:srgbClr val="1E2D33"/>
                 </a:solidFill>
@@ -6831,9 +7441,9 @@
                 <a:ea typeface="Calibri" pitchFamily="34" charset="-122"/>
                 <a:cs typeface="Calibri" pitchFamily="34" charset="-120"/>
               </a:rPr>
-              <a:t>La label propagation réutilise les features ResNet</a:t>
-            </a:r>
-            <a:endParaRPr lang="en-US" sz="1400" dirty="0"/>
+              <a:t>AUC 0,947 ± 0,022</a:t>
+            </a:r>
+            <a:endParaRPr lang="en-US" sz="1350" dirty="0"/>
           </a:p>
         </p:txBody>
       </p:sp>
@@ -6845,8 +7455,8 @@
         </p:nvSpPr>
         <p:spPr>
           <a:xfrm>
-            <a:off x="1371600" y="2898648"/>
-            <a:ext cx="7178040" cy="457200"/>
+            <a:off x="5532120" y="1892808"/>
+            <a:ext cx="2971800" cy="841248"/>
           </a:xfrm>
           <a:prstGeom prst="rect">
             <a:avLst/>
@@ -6862,7 +7472,7 @@
               <a:buNone/>
             </a:pPr>
             <a:r>
-              <a:rPr lang="en-US" sz="1150" dirty="0">
+              <a:rPr lang="en-US" sz="1080" dirty="0">
                 <a:solidFill>
                   <a:srgbClr val="5B7179"/>
                 </a:solidFill>
@@ -6870,9 +7480,9 @@
                 <a:ea typeface="Calibri" pitchFamily="34" charset="-122"/>
                 <a:cs typeface="Calibri" pitchFamily="34" charset="-120"/>
               </a:rPr>
-              <a:t>Aucun CNN à entraîner : elle propage les 70 vrais labels à travers le graphe de similarité des embeddings pré-entraînés.</a:t>
-            </a:r>
-            <a:endParaRPr lang="en-US" sz="1150" dirty="0"/>
+              <a:t>Sur 5 découpages indépendants — performance stable, pas un coup de chance.</a:t>
+            </a:r>
+            <a:endParaRPr lang="en-US" sz="1080" dirty="0"/>
           </a:p>
         </p:txBody>
       </p:sp>
@@ -6884,16 +7494,16 @@
         </p:nvSpPr>
         <p:spPr>
           <a:xfrm>
-            <a:off x="457200" y="3520440"/>
-            <a:ext cx="8229600" cy="987552"/>
+            <a:off x="457200" y="2926080"/>
+            <a:ext cx="4023360" cy="1481328"/>
           </a:xfrm>
           <a:prstGeom prst="roundRect">
             <a:avLst>
-              <a:gd name="adj" fmla="val 7407"/>
+              <a:gd name="adj" fmla="val 4938"/>
             </a:avLst>
           </a:prstGeom>
           <a:solidFill>
-            <a:srgbClr val="FFFFFF"/>
+            <a:srgbClr val="EFF6F7"/>
           </a:solidFill>
           <a:ln/>
           <a:effectLst>
@@ -6913,14 +7523,14 @@
         </p:nvSpPr>
         <p:spPr>
           <a:xfrm>
-            <a:off x="658368" y="3758184"/>
+            <a:off x="658368" y="3154680"/>
             <a:ext cx="512064" cy="512064"/>
           </a:xfrm>
           <a:prstGeom prst="ellipse">
             <a:avLst/>
           </a:prstGeom>
           <a:solidFill>
-            <a:srgbClr val="12B5A5"/>
+            <a:srgbClr val="0C7B8C"/>
           </a:solidFill>
           <a:ln/>
           <a:effectLst>
@@ -6948,7 +7558,7 @@
         </p:blipFill>
         <p:spPr>
           <a:xfrm>
-            <a:off x="777240" y="3877056"/>
+            <a:off x="777240" y="3273552"/>
             <a:ext cx="274320" cy="274320"/>
           </a:xfrm>
           <a:prstGeom prst="rect">
@@ -6964,8 +7574,8 @@
         </p:nvSpPr>
         <p:spPr>
           <a:xfrm>
-            <a:off x="1371600" y="3648456"/>
-            <a:ext cx="7132320" cy="365760"/>
+            <a:off x="1325880" y="3090672"/>
+            <a:ext cx="3017520" cy="457200"/>
           </a:xfrm>
           <a:prstGeom prst="rect">
             <a:avLst/>
@@ -6981,7 +7591,7 @@
               <a:buNone/>
             </a:pPr>
             <a:r>
-              <a:rPr lang="en-US" sz="1400" b="1" dirty="0">
+              <a:rPr lang="en-US" sz="1350" b="1" dirty="0">
                 <a:solidFill>
                   <a:srgbClr val="1E2D33"/>
                 </a:solidFill>
@@ -6989,9 +7599,9 @@
                 <a:ea typeface="Calibri" pitchFamily="34" charset="-122"/>
                 <a:cs typeface="Calibri" pitchFamily="34" charset="-120"/>
               </a:rPr>
-              <a:t>Résultat : F1 0,91 et rappel 0,87 (sur 5 découpages)</a:t>
-            </a:r>
-            <a:endParaRPr lang="en-US" sz="1400" dirty="0"/>
+              <a:t>Hyperparamètres balayés</a:t>
+            </a:r>
+            <a:endParaRPr lang="en-US" sz="1350" dirty="0"/>
           </a:p>
         </p:txBody>
       </p:sp>
@@ -7003,8 +7613,8 @@
         </p:nvSpPr>
         <p:spPr>
           <a:xfrm>
-            <a:off x="1371600" y="3995928"/>
-            <a:ext cx="7178040" cy="457200"/>
+            <a:off x="1325880" y="3493008"/>
+            <a:ext cx="2971800" cy="841248"/>
           </a:xfrm>
           <a:prstGeom prst="rect">
             <a:avLst/>
@@ -7020,7 +7630,7 @@
               <a:buNone/>
             </a:pPr>
             <a:r>
-              <a:rPr lang="en-US" sz="1150" dirty="0">
+              <a:rPr lang="en-US" sz="1080" dirty="0">
                 <a:solidFill>
                   <a:srgbClr val="5B7179"/>
                 </a:solidFill>
@@ -7028,9 +7638,167 @@
                 <a:ea typeface="Calibri" pitchFamily="34" charset="-122"/>
                 <a:cs typeface="Calibri" pitchFamily="34" charset="-120"/>
               </a:rPr>
-              <a:t>Le semi-supervisé apporte bien un gain — le verrou n'était pas l'idée, mais le véhicule : un CNN entraîné de zéro sur trop peu de données.</a:t>
-            </a:r>
-            <a:endParaRPr lang="en-US" sz="1150" dirty="0"/>
+              <a:t>n_neighbors = 12 confirmé optimal (F1 0,91), robuste au paramètre alpha.</a:t>
+            </a:r>
+            <a:endParaRPr lang="en-US" sz="1080" dirty="0"/>
+          </a:p>
+        </p:txBody>
+      </p:sp>
+      <p:sp>
+        <p:nvSpPr>
+          <p:cNvPr id="20" name="Shape 14"/>
+          <p:cNvSpPr/>
+          <p:nvPr/>
+        </p:nvSpPr>
+        <p:spPr>
+          <a:xfrm>
+            <a:off x="4663440" y="2926080"/>
+            <a:ext cx="4023360" cy="1481328"/>
+          </a:xfrm>
+          <a:prstGeom prst="roundRect">
+            <a:avLst>
+              <a:gd name="adj" fmla="val 4938"/>
+            </a:avLst>
+          </a:prstGeom>
+          <a:solidFill>
+            <a:srgbClr val="EFF6F7"/>
+          </a:solidFill>
+          <a:ln/>
+          <a:effectLst>
+            <a:outerShdw sx="100000" sy="100000" kx="0" ky="0" algn="bl" rotWithShape="0" blurRad="88900" dist="38100" dir="5400000">
+              <a:srgbClr val="000000">
+                <a:alpha val="13000"/>
+              </a:srgbClr>
+            </a:outerShdw>
+          </a:effectLst>
+        </p:spPr>
+      </p:sp>
+      <p:sp>
+        <p:nvSpPr>
+          <p:cNvPr id="21" name="Shape 15"/>
+          <p:cNvSpPr/>
+          <p:nvPr/>
+        </p:nvSpPr>
+        <p:spPr>
+          <a:xfrm>
+            <a:off x="4864608" y="3154680"/>
+            <a:ext cx="512064" cy="512064"/>
+          </a:xfrm>
+          <a:prstGeom prst="ellipse">
+            <a:avLst/>
+          </a:prstGeom>
+          <a:solidFill>
+            <a:srgbClr val="0C7B8C"/>
+          </a:solidFill>
+          <a:ln/>
+          <a:effectLst>
+            <a:outerShdw sx="100000" sy="100000" kx="0" ky="0" algn="bl" rotWithShape="0" blurRad="88900" dist="38100" dir="5400000">
+              <a:srgbClr val="000000">
+                <a:alpha val="13000"/>
+              </a:srgbClr>
+            </a:outerShdw>
+          </a:effectLst>
+        </p:spPr>
+      </p:sp>
+      <p:pic>
+        <p:nvPicPr>
+          <p:cNvPr id="22" name="Image 4" descr="preencoded.png">    </p:cNvPr>
+          <p:cNvPicPr>
+            <a:picLocks noChangeAspect="1"/>
+          </p:cNvPicPr>
+          <p:nvPr/>
+        </p:nvPicPr>
+        <p:blipFill>
+          <a:blip r:embed="rId5"/>
+          <a:stretch>
+            <a:fillRect/>
+          </a:stretch>
+        </p:blipFill>
+        <p:spPr>
+          <a:xfrm>
+            <a:off x="4983480" y="3273552"/>
+            <a:ext cx="274320" cy="274320"/>
+          </a:xfrm>
+          <a:prstGeom prst="rect">
+            <a:avLst/>
+          </a:prstGeom>
+        </p:spPr>
+      </p:pic>
+      <p:sp>
+        <p:nvSpPr>
+          <p:cNvPr id="23" name="Text 16"/>
+          <p:cNvSpPr/>
+          <p:nvPr/>
+        </p:nvSpPr>
+        <p:spPr>
+          <a:xfrm>
+            <a:off x="5532120" y="3090672"/>
+            <a:ext cx="3017520" cy="457200"/>
+          </a:xfrm>
+          <a:prstGeom prst="rect">
+            <a:avLst/>
+          </a:prstGeom>
+          <a:noFill/>
+          <a:ln/>
+        </p:spPr>
+        <p:txBody>
+          <a:bodyPr wrap="square" lIns="0" tIns="0" rIns="0" bIns="0" rtlCol="0" anchor="ctr"/>
+          <a:lstStyle/>
+          <a:p>
+            <a:pPr indent="0" marL="0">
+              <a:buNone/>
+            </a:pPr>
+            <a:r>
+              <a:rPr lang="en-US" sz="1350" b="1" dirty="0">
+                <a:solidFill>
+                  <a:srgbClr val="1E2D33"/>
+                </a:solidFill>
+                <a:latin typeface="Calibri" pitchFamily="34" charset="0"/>
+                <a:ea typeface="Calibri" pitchFamily="34" charset="-122"/>
+                <a:cs typeface="Calibri" pitchFamily="34" charset="-120"/>
+              </a:rPr>
+              <a:t>Données contrôlées</a:t>
+            </a:r>
+            <a:endParaRPr lang="en-US" sz="1350" dirty="0"/>
+          </a:p>
+        </p:txBody>
+      </p:sp>
+      <p:sp>
+        <p:nvSpPr>
+          <p:cNvPr id="24" name="Text 17"/>
+          <p:cNvSpPr/>
+          <p:nvPr/>
+        </p:nvSpPr>
+        <p:spPr>
+          <a:xfrm>
+            <a:off x="5532120" y="3493008"/>
+            <a:ext cx="2971800" cy="841248"/>
+          </a:xfrm>
+          <a:prstGeom prst="rect">
+            <a:avLst/>
+          </a:prstGeom>
+          <a:noFill/>
+          <a:ln/>
+        </p:spPr>
+        <p:txBody>
+          <a:bodyPr wrap="square" lIns="0" tIns="0" rIns="0" bIns="0" rtlCol="0" anchor="ctr"/>
+          <a:lstStyle/>
+          <a:p>
+            <a:pPr indent="0" marL="0">
+              <a:buNone/>
+            </a:pPr>
+            <a:r>
+              <a:rPr lang="en-US" sz="1080" dirty="0">
+                <a:solidFill>
+                  <a:srgbClr val="5B7179"/>
+                </a:solidFill>
+                <a:latin typeface="Calibri" pitchFamily="34" charset="0"/>
+                <a:ea typeface="Calibri" pitchFamily="34" charset="-122"/>
+                <a:cs typeface="Calibri" pitchFamily="34" charset="-120"/>
+              </a:rPr>
+              <a:t>31 images atypiques inspectées : IRM différentes mais saines, aucun retrait nécessaire.</a:t>
+            </a:r>
+            <a:endParaRPr lang="en-US" sz="1080" dirty="0"/>
           </a:p>
         </p:txBody>
       </p:sp>
@@ -7150,7 +7918,7 @@
                 <a:ea typeface="Calibri" pitchFamily="34" charset="-122"/>
                 <a:cs typeface="Calibri" pitchFamily="34" charset="-120"/>
               </a:rPr>
-              <a:t>Métrique prioritaire &amp; « definition of done »</a:t>
+              <a:t>Ce que révèle la comparaison</a:t>
             </a:r>
             <a:endParaRPr lang="en-US" sz="2600" dirty="0"/>
           </a:p>
@@ -7164,16 +7932,16 @@
         </p:nvSpPr>
         <p:spPr>
           <a:xfrm>
-            <a:off x="457200" y="1280160"/>
-            <a:ext cx="4023360" cy="3337560"/>
+            <a:off x="457200" y="1325880"/>
+            <a:ext cx="8229600" cy="987552"/>
           </a:xfrm>
           <a:prstGeom prst="roundRect">
             <a:avLst>
-              <a:gd name="adj" fmla="val 2192"/>
+              <a:gd name="adj" fmla="val 7407"/>
             </a:avLst>
           </a:prstGeom>
           <a:solidFill>
-            <a:srgbClr val="EFF6F7"/>
+            <a:srgbClr val="FFFFFF"/>
           </a:solidFill>
           <a:ln/>
           <a:effectLst>
@@ -7193,8 +7961,8 @@
         </p:nvSpPr>
         <p:spPr>
           <a:xfrm>
-            <a:off x="685800" y="1481328"/>
-            <a:ext cx="548640" cy="548640"/>
+            <a:off x="658368" y="1563624"/>
+            <a:ext cx="512064" cy="512064"/>
           </a:xfrm>
           <a:prstGeom prst="ellipse">
             <a:avLst/>
@@ -7228,8 +7996,8 @@
         </p:blipFill>
         <p:spPr>
           <a:xfrm>
-            <a:off x="813816" y="1609344"/>
-            <a:ext cx="292608" cy="292608"/>
+            <a:off x="777240" y="1682496"/>
+            <a:ext cx="274320" cy="274320"/>
           </a:xfrm>
           <a:prstGeom prst="rect">
             <a:avLst/>
@@ -7244,8 +8012,8 @@
         </p:nvSpPr>
         <p:spPr>
           <a:xfrm>
-            <a:off x="1371600" y="1517904"/>
-            <a:ext cx="3017520" cy="502920"/>
+            <a:off x="1371600" y="1453896"/>
+            <a:ext cx="7132320" cy="365760"/>
           </a:xfrm>
           <a:prstGeom prst="rect">
             <a:avLst/>
@@ -7261,7 +8029,7 @@
               <a:buNone/>
             </a:pPr>
             <a:r>
-              <a:rPr lang="en-US" sz="1450" b="1" dirty="0">
+              <a:rPr lang="en-US" sz="1400" b="1" dirty="0">
                 <a:solidFill>
                   <a:srgbClr val="1E2D33"/>
                 </a:solidFill>
@@ -7269,9 +8037,9 @@
                 <a:ea typeface="Calibri" pitchFamily="34" charset="-122"/>
                 <a:cs typeface="Calibri" pitchFamily="34" charset="-120"/>
               </a:rPr>
-              <a:t>Pourquoi le rappel sur le cancer</a:t>
-            </a:r>
-            <a:endParaRPr lang="en-US" sz="1450" dirty="0"/>
+              <a:t>Les CNN appris de zéro plafonnent</a:t>
+            </a:r>
+            <a:endParaRPr lang="en-US" sz="1400" dirty="0"/>
           </a:p>
         </p:txBody>
       </p:sp>
@@ -7283,8 +8051,8 @@
         </p:nvSpPr>
         <p:spPr>
           <a:xfrm>
-            <a:off x="685800" y="2194560"/>
-            <a:ext cx="3611880" cy="2286000"/>
+            <a:off x="1371600" y="1801368"/>
+            <a:ext cx="7178040" cy="457200"/>
           </a:xfrm>
           <a:prstGeom prst="rect">
             <a:avLst/>
@@ -7297,63 +8065,20 @@
           <a:lstStyle/>
           <a:p>
             <a:pPr indent="0" marL="0">
-              <a:spcAft>
-                <a:spcPts val="900"/>
-              </a:spcAft>
-              <a:buNone/>
-            </a:pPr>
-            <a:r>
-              <a:rPr lang="en-US" sz="1250" dirty="0">
-                <a:solidFill>
-                  <a:srgbClr val="1E2D33"/>
-                </a:solidFill>
-                <a:latin typeface="Calibri" pitchFamily="34" charset="0"/>
-                <a:ea typeface="Calibri" pitchFamily="34" charset="-122"/>
-                <a:cs typeface="Calibri" pitchFamily="34" charset="-120"/>
-              </a:rPr>
-              <a:t>Faux négatif = tumeur manquée = patient non pris en charge. C'est l'erreur la plus grave.</a:t>
-            </a:r>
-            <a:endParaRPr lang="en-US" sz="1250" dirty="0"/>
-          </a:p>
-          <a:p>
-            <a:pPr indent="0" marL="0">
-              <a:spcAft>
-                <a:spcPts val="900"/>
-              </a:spcAft>
-              <a:buNone/>
-            </a:pPr>
-            <a:r>
-              <a:rPr lang="en-US" sz="1250" dirty="0">
-                <a:solidFill>
-                  <a:srgbClr val="1E2D33"/>
-                </a:solidFill>
-                <a:latin typeface="Calibri" pitchFamily="34" charset="0"/>
-                <a:ea typeface="Calibri" pitchFamily="34" charset="-122"/>
-                <a:cs typeface="Calibri" pitchFamily="34" charset="-120"/>
-              </a:rPr>
-              <a:t>Une fausse alerte (faux positif) coûte un examen complémentaire — bien moins lourd.</a:t>
-            </a:r>
-            <a:endParaRPr lang="en-US" sz="1250" dirty="0"/>
-          </a:p>
-          <a:p>
-            <a:pPr indent="0" marL="0">
-              <a:spcAft>
-                <a:spcPts val="900"/>
-              </a:spcAft>
-              <a:buNone/>
-            </a:pPr>
-            <a:r>
-              <a:rPr lang="en-US" sz="1250" dirty="0">
-                <a:solidFill>
-                  <a:srgbClr val="1E2D33"/>
-                </a:solidFill>
-                <a:latin typeface="Calibri" pitchFamily="34" charset="0"/>
-                <a:ea typeface="Calibri" pitchFamily="34" charset="-122"/>
-                <a:cs typeface="Calibri" pitchFamily="34" charset="-120"/>
-              </a:rPr>
-              <a:t>→ On optimise le rappel cancer, F1 comme compromis. L'accuracy seule serait trompeuse.</a:t>
-            </a:r>
-            <a:endParaRPr lang="en-US" sz="1250" dirty="0"/>
+              <a:buNone/>
+            </a:pPr>
+            <a:r>
+              <a:rPr lang="en-US" sz="1150" dirty="0">
+                <a:solidFill>
+                  <a:srgbClr val="5B7179"/>
+                </a:solidFill>
+                <a:latin typeface="Calibri" pitchFamily="34" charset="0"/>
+                <a:ea typeface="Calibri" pitchFamily="34" charset="-122"/>
+                <a:cs typeface="Calibri" pitchFamily="34" charset="-120"/>
+              </a:rPr>
+              <a:t>Avec 70 (ou 1 406 bruitées) images, le CNN apprend mal ses propres features : supervisé et clustering-semi restent à égalité (F1 ≈ 0,72).</a:t>
+            </a:r>
+            <a:endParaRPr lang="en-US" sz="1150" dirty="0"/>
           </a:p>
         </p:txBody>
       </p:sp>
@@ -7365,16 +8090,16 @@
         </p:nvSpPr>
         <p:spPr>
           <a:xfrm>
-            <a:off x="4663440" y="1280160"/>
-            <a:ext cx="4023360" cy="3337560"/>
+            <a:off x="457200" y="2423160"/>
+            <a:ext cx="8229600" cy="987552"/>
           </a:xfrm>
           <a:prstGeom prst="roundRect">
             <a:avLst>
-              <a:gd name="adj" fmla="val 2192"/>
+              <a:gd name="adj" fmla="val 7407"/>
             </a:avLst>
           </a:prstGeom>
           <a:solidFill>
-            <a:srgbClr val="EFF6F7"/>
+            <a:srgbClr val="FFFFFF"/>
           </a:solidFill>
           <a:ln/>
           <a:effectLst>
@@ -7394,8 +8119,8 @@
         </p:nvSpPr>
         <p:spPr>
           <a:xfrm>
-            <a:off x="4892040" y="1481328"/>
-            <a:ext cx="548640" cy="548640"/>
+            <a:off x="658368" y="2660904"/>
+            <a:ext cx="512064" cy="512064"/>
           </a:xfrm>
           <a:prstGeom prst="ellipse">
             <a:avLst/>
@@ -7429,8 +8154,8 @@
         </p:blipFill>
         <p:spPr>
           <a:xfrm>
-            <a:off x="5020056" y="1609344"/>
-            <a:ext cx="292608" cy="292608"/>
+            <a:off x="777240" y="2779776"/>
+            <a:ext cx="274320" cy="274320"/>
           </a:xfrm>
           <a:prstGeom prst="rect">
             <a:avLst/>
@@ -7445,8 +8170,8 @@
         </p:nvSpPr>
         <p:spPr>
           <a:xfrm>
-            <a:off x="5577840" y="1517904"/>
-            <a:ext cx="2926080" cy="502920"/>
+            <a:off x="1371600" y="2551176"/>
+            <a:ext cx="7132320" cy="365760"/>
           </a:xfrm>
           <a:prstGeom prst="rect">
             <a:avLst/>
@@ -7462,7 +8187,7 @@
               <a:buNone/>
             </a:pPr>
             <a:r>
-              <a:rPr lang="en-US" sz="1450" b="1" dirty="0">
+              <a:rPr lang="en-US" sz="1400" b="1" dirty="0">
                 <a:solidFill>
                   <a:srgbClr val="1E2D33"/>
                 </a:solidFill>
@@ -7470,9 +8195,9 @@
                 <a:ea typeface="Calibri" pitchFamily="34" charset="-122"/>
                 <a:cs typeface="Calibri" pitchFamily="34" charset="-120"/>
               </a:rPr>
-              <a:t>Definition of done</a:t>
-            </a:r>
-            <a:endParaRPr lang="en-US" sz="1450" dirty="0"/>
+              <a:t>La label propagation réutilise les features ResNet</a:t>
+            </a:r>
+            <a:endParaRPr lang="en-US" sz="1400" dirty="0"/>
           </a:p>
         </p:txBody>
       </p:sp>
@@ -7484,8 +8209,8 @@
         </p:nvSpPr>
         <p:spPr>
           <a:xfrm>
-            <a:off x="4892040" y="2194560"/>
-            <a:ext cx="3611880" cy="2286000"/>
+            <a:off x="1371600" y="2898648"/>
+            <a:ext cx="7178040" cy="457200"/>
           </a:xfrm>
           <a:prstGeom prst="rect">
             <a:avLst/>
@@ -7497,15 +8222,130 @@
           <a:bodyPr wrap="square" lIns="0" tIns="0" rIns="0" bIns="0" rtlCol="0" anchor="ctr"/>
           <a:lstStyle/>
           <a:p>
-            <a:pPr marL="342900" indent="-342900">
-              <a:spcAft>
-                <a:spcPts val="900"/>
-              </a:spcAft>
-              <a:buSzPct val="100000"/>
-              <a:buChar char="•"/>
-            </a:pPr>
-            <a:r>
-              <a:rPr lang="en-US" sz="1250" dirty="0">
+            <a:pPr indent="0" marL="0">
+              <a:buNone/>
+            </a:pPr>
+            <a:r>
+              <a:rPr lang="en-US" sz="1150" dirty="0">
+                <a:solidFill>
+                  <a:srgbClr val="5B7179"/>
+                </a:solidFill>
+                <a:latin typeface="Calibri" pitchFamily="34" charset="0"/>
+                <a:ea typeface="Calibri" pitchFamily="34" charset="-122"/>
+                <a:cs typeface="Calibri" pitchFamily="34" charset="-120"/>
+              </a:rPr>
+              <a:t>Aucun CNN à entraîner : elle propage les 70 vrais labels à travers le graphe de similarité des embeddings pré-entraînés.</a:t>
+            </a:r>
+            <a:endParaRPr lang="en-US" sz="1150" dirty="0"/>
+          </a:p>
+        </p:txBody>
+      </p:sp>
+      <p:sp>
+        <p:nvSpPr>
+          <p:cNvPr id="15" name="Shape 10"/>
+          <p:cNvSpPr/>
+          <p:nvPr/>
+        </p:nvSpPr>
+        <p:spPr>
+          <a:xfrm>
+            <a:off x="457200" y="3520440"/>
+            <a:ext cx="8229600" cy="987552"/>
+          </a:xfrm>
+          <a:prstGeom prst="roundRect">
+            <a:avLst>
+              <a:gd name="adj" fmla="val 7407"/>
+            </a:avLst>
+          </a:prstGeom>
+          <a:solidFill>
+            <a:srgbClr val="FFFFFF"/>
+          </a:solidFill>
+          <a:ln/>
+          <a:effectLst>
+            <a:outerShdw sx="100000" sy="100000" kx="0" ky="0" algn="bl" rotWithShape="0" blurRad="88900" dist="38100" dir="5400000">
+              <a:srgbClr val="000000">
+                <a:alpha val="13000"/>
+              </a:srgbClr>
+            </a:outerShdw>
+          </a:effectLst>
+        </p:spPr>
+      </p:sp>
+      <p:sp>
+        <p:nvSpPr>
+          <p:cNvPr id="16" name="Shape 11"/>
+          <p:cNvSpPr/>
+          <p:nvPr/>
+        </p:nvSpPr>
+        <p:spPr>
+          <a:xfrm>
+            <a:off x="658368" y="3758184"/>
+            <a:ext cx="512064" cy="512064"/>
+          </a:xfrm>
+          <a:prstGeom prst="ellipse">
+            <a:avLst/>
+          </a:prstGeom>
+          <a:solidFill>
+            <a:srgbClr val="12B5A5"/>
+          </a:solidFill>
+          <a:ln/>
+          <a:effectLst>
+            <a:outerShdw sx="100000" sy="100000" kx="0" ky="0" algn="bl" rotWithShape="0" blurRad="88900" dist="38100" dir="5400000">
+              <a:srgbClr val="000000">
+                <a:alpha val="13000"/>
+              </a:srgbClr>
+            </a:outerShdw>
+          </a:effectLst>
+        </p:spPr>
+      </p:sp>
+      <p:pic>
+        <p:nvPicPr>
+          <p:cNvPr id="17" name="Image 3" descr="preencoded.png">    </p:cNvPr>
+          <p:cNvPicPr>
+            <a:picLocks noChangeAspect="1"/>
+          </p:cNvPicPr>
+          <p:nvPr/>
+        </p:nvPicPr>
+        <p:blipFill>
+          <a:blip r:embed="rId4"/>
+          <a:stretch>
+            <a:fillRect/>
+          </a:stretch>
+        </p:blipFill>
+        <p:spPr>
+          <a:xfrm>
+            <a:off x="777240" y="3877056"/>
+            <a:ext cx="274320" cy="274320"/>
+          </a:xfrm>
+          <a:prstGeom prst="rect">
+            <a:avLst/>
+          </a:prstGeom>
+        </p:spPr>
+      </p:pic>
+      <p:sp>
+        <p:nvSpPr>
+          <p:cNvPr id="18" name="Text 12"/>
+          <p:cNvSpPr/>
+          <p:nvPr/>
+        </p:nvSpPr>
+        <p:spPr>
+          <a:xfrm>
+            <a:off x="1371600" y="3648456"/>
+            <a:ext cx="7132320" cy="365760"/>
+          </a:xfrm>
+          <a:prstGeom prst="rect">
+            <a:avLst/>
+          </a:prstGeom>
+          <a:noFill/>
+          <a:ln/>
+        </p:spPr>
+        <p:txBody>
+          <a:bodyPr wrap="square" lIns="0" tIns="0" rIns="0" bIns="0" rtlCol="0" anchor="ctr"/>
+          <a:lstStyle/>
+          <a:p>
+            <a:pPr indent="0" marL="0">
+              <a:buNone/>
+            </a:pPr>
+            <a:r>
+              <a:rPr lang="en-US" sz="1400" b="1" dirty="0">
                 <a:solidFill>
                   <a:srgbClr val="1E2D33"/>
                 </a:solidFill>
@@ -7513,72 +8353,48 @@
                 <a:ea typeface="Calibri" pitchFamily="34" charset="-122"/>
                 <a:cs typeface="Calibri" pitchFamily="34" charset="-120"/>
               </a:rPr>
-              <a:t>Protocole sans aucune fuite test ↔ entraînement (vérifié : 0)</a:t>
-            </a:r>
-            <a:endParaRPr lang="en-US" sz="1250" dirty="0"/>
-          </a:p>
-          <a:p>
-            <a:pPr marL="342900" indent="-342900">
-              <a:spcAft>
-                <a:spcPts val="900"/>
-              </a:spcAft>
-              <a:buSzPct val="100000"/>
-              <a:buChar char="•"/>
-            </a:pPr>
-            <a:r>
-              <a:rPr lang="en-US" sz="1250" dirty="0">
-                <a:solidFill>
-                  <a:srgbClr val="1E2D33"/>
-                </a:solidFill>
-                <a:latin typeface="Calibri" pitchFamily="34" charset="0"/>
-                <a:ea typeface="Calibri" pitchFamily="34" charset="-122"/>
-                <a:cs typeface="Calibri" pitchFamily="34" charset="-120"/>
-              </a:rPr>
-              <a:t>Rappel &amp; F1 cancer rapportés sur un test jamais vu</a:t>
-            </a:r>
-            <a:endParaRPr lang="en-US" sz="1250" dirty="0"/>
-          </a:p>
-          <a:p>
-            <a:pPr marL="342900" indent="-342900">
-              <a:spcAft>
-                <a:spcPts val="900"/>
-              </a:spcAft>
-              <a:buSzPct val="100000"/>
-              <a:buChar char="•"/>
-            </a:pPr>
-            <a:r>
-              <a:rPr lang="en-US" sz="1250" dirty="0">
-                <a:solidFill>
-                  <a:srgbClr val="1E2D33"/>
-                </a:solidFill>
-                <a:latin typeface="Calibri" pitchFamily="34" charset="0"/>
-                <a:ea typeface="Calibri" pitchFamily="34" charset="-122"/>
-                <a:cs typeface="Calibri" pitchFamily="34" charset="-120"/>
-              </a:rPr>
-              <a:t>Comparaison chiffrée supervisé vs semi, moyennée sur plusieurs graines</a:t>
-            </a:r>
-            <a:endParaRPr lang="en-US" sz="1250" dirty="0"/>
-          </a:p>
-          <a:p>
-            <a:pPr marL="342900" indent="-342900">
-              <a:spcAft>
-                <a:spcPts val="900"/>
-              </a:spcAft>
-              <a:buSzPct val="100000"/>
-              <a:buChar char="•"/>
-            </a:pPr>
-            <a:r>
-              <a:rPr lang="en-US" sz="1250" dirty="0">
-                <a:solidFill>
-                  <a:srgbClr val="1E2D33"/>
-                </a:solidFill>
-                <a:latin typeface="Calibri" pitchFamily="34" charset="0"/>
-                <a:ea typeface="Calibri" pitchFamily="34" charset="-122"/>
-                <a:cs typeface="Calibri" pitchFamily="34" charset="-120"/>
-              </a:rPr>
-              <a:t>Succès « fort » = le semi égale ou dépasse le supervisé en rappel cancer</a:t>
-            </a:r>
-            <a:endParaRPr lang="en-US" sz="1250" dirty="0"/>
+              <a:t>Résultat : F1 0,91 et rappel 0,87 (sur 5 découpages)</a:t>
+            </a:r>
+            <a:endParaRPr lang="en-US" sz="1400" dirty="0"/>
+          </a:p>
+        </p:txBody>
+      </p:sp>
+      <p:sp>
+        <p:nvSpPr>
+          <p:cNvPr id="19" name="Text 13"/>
+          <p:cNvSpPr/>
+          <p:nvPr/>
+        </p:nvSpPr>
+        <p:spPr>
+          <a:xfrm>
+            <a:off x="1371600" y="3995928"/>
+            <a:ext cx="7178040" cy="457200"/>
+          </a:xfrm>
+          <a:prstGeom prst="rect">
+            <a:avLst/>
+          </a:prstGeom>
+          <a:noFill/>
+          <a:ln/>
+        </p:spPr>
+        <p:txBody>
+          <a:bodyPr wrap="square" lIns="0" tIns="0" rIns="0" bIns="0" rtlCol="0" anchor="ctr"/>
+          <a:lstStyle/>
+          <a:p>
+            <a:pPr indent="0" marL="0">
+              <a:buNone/>
+            </a:pPr>
+            <a:r>
+              <a:rPr lang="en-US" sz="1150" dirty="0">
+                <a:solidFill>
+                  <a:srgbClr val="5B7179"/>
+                </a:solidFill>
+                <a:latin typeface="Calibri" pitchFamily="34" charset="0"/>
+                <a:ea typeface="Calibri" pitchFamily="34" charset="-122"/>
+                <a:cs typeface="Calibri" pitchFamily="34" charset="-120"/>
+              </a:rPr>
+              <a:t>Le semi-supervisé apporte bien un gain — le verrou n'était pas l'idée, mais le véhicule : un CNN entraîné de zéro sur trop peu de données.</a:t>
+            </a:r>
+            <a:endParaRPr lang="en-US" sz="1150" dirty="0"/>
           </a:p>
         </p:txBody>
       </p:sp>
@@ -7698,7 +8514,7 @@
                 <a:ea typeface="Calibri" pitchFamily="34" charset="-122"/>
                 <a:cs typeface="Calibri" pitchFamily="34" charset="-120"/>
               </a:rPr>
-              <a:t>Passage à l'échelle : l'économie</a:t>
+              <a:t>Métrique prioritaire &amp; « definition of done »</a:t>
             </a:r>
             <a:endParaRPr lang="en-US" sz="2600" dirty="0"/>
           </a:p>
@@ -7706,57 +8522,18 @@
       </p:sp>
       <p:sp>
         <p:nvSpPr>
-          <p:cNvPr id="5" name="Text 2"/>
-          <p:cNvSpPr/>
-          <p:nvPr/>
-        </p:nvSpPr>
-        <p:spPr>
-          <a:xfrm>
-            <a:off x="457200" y="1115568"/>
-            <a:ext cx="8229600" cy="365760"/>
-          </a:xfrm>
-          <a:prstGeom prst="rect">
-            <a:avLst/>
-          </a:prstGeom>
-          <a:noFill/>
-          <a:ln/>
-        </p:spPr>
-        <p:txBody>
-          <a:bodyPr wrap="square" lIns="0" tIns="0" rIns="0" bIns="0" rtlCol="0" anchor="ctr"/>
-          <a:lstStyle/>
-          <a:p>
-            <a:pPr indent="0" marL="0">
-              <a:buNone/>
-            </a:pPr>
-            <a:r>
-              <a:rPr lang="en-US" sz="1500" b="1" dirty="0">
-                <a:solidFill>
-                  <a:srgbClr val="1E2D33"/>
-                </a:solidFill>
-                <a:latin typeface="Calibri" pitchFamily="34" charset="0"/>
-                <a:ea typeface="Calibri" pitchFamily="34" charset="-122"/>
-                <a:cs typeface="Calibri" pitchFamily="34" charset="-120"/>
-              </a:rPr>
-              <a:t>Cible : 5 000 € pour labelliser 4 millions d'images.</a:t>
-            </a:r>
-            <a:endParaRPr lang="en-US" sz="1500" dirty="0"/>
-          </a:p>
-        </p:txBody>
-      </p:sp>
-      <p:sp>
-        <p:nvSpPr>
-          <p:cNvPr id="6" name="Shape 3"/>
-          <p:cNvSpPr/>
-          <p:nvPr/>
-        </p:nvSpPr>
-        <p:spPr>
-          <a:xfrm>
-            <a:off x="457200" y="1828800"/>
-            <a:ext cx="2670048" cy="2103120"/>
+          <p:cNvPr id="5" name="Shape 2"/>
+          <p:cNvSpPr/>
+          <p:nvPr/>
+        </p:nvSpPr>
+        <p:spPr>
+          <a:xfrm>
+            <a:off x="457200" y="1280160"/>
+            <a:ext cx="4023360" cy="3337560"/>
           </a:xfrm>
           <a:prstGeom prst="roundRect">
             <a:avLst>
-              <a:gd name="adj" fmla="val 3478"/>
+              <a:gd name="adj" fmla="val 2192"/>
             </a:avLst>
           </a:prstGeom>
           <a:solidFill>
@@ -7774,100 +8551,20 @@
       </p:sp>
       <p:sp>
         <p:nvSpPr>
-          <p:cNvPr id="7" name="Text 4"/>
-          <p:cNvSpPr/>
-          <p:nvPr/>
-        </p:nvSpPr>
-        <p:spPr>
-          <a:xfrm>
-            <a:off x="457200" y="2240280"/>
-            <a:ext cx="2670048" cy="731520"/>
-          </a:xfrm>
-          <a:prstGeom prst="rect">
-            <a:avLst/>
-          </a:prstGeom>
-          <a:noFill/>
-          <a:ln/>
-        </p:spPr>
-        <p:txBody>
-          <a:bodyPr wrap="square" lIns="0" tIns="0" rIns="0" bIns="0" rtlCol="0" anchor="ctr"/>
-          <a:lstStyle/>
-          <a:p>
-            <a:pPr algn="ctr" indent="0" marL="0">
-              <a:buNone/>
-            </a:pPr>
-            <a:r>
-              <a:rPr lang="en-US" sz="4000" b="1" dirty="0">
-                <a:solidFill>
-                  <a:srgbClr val="5B7179"/>
-                </a:solidFill>
-                <a:latin typeface="Calibri" pitchFamily="34" charset="0"/>
-                <a:ea typeface="Calibri" pitchFamily="34" charset="-122"/>
-                <a:cs typeface="Calibri" pitchFamily="34" charset="-120"/>
-              </a:rPr>
-              <a:t>0,20 €</a:t>
-            </a:r>
-            <a:endParaRPr lang="en-US" sz="4000" dirty="0"/>
-          </a:p>
-        </p:txBody>
-      </p:sp>
-      <p:sp>
-        <p:nvSpPr>
-          <p:cNvPr id="8" name="Text 5"/>
-          <p:cNvSpPr/>
-          <p:nvPr/>
-        </p:nvSpPr>
-        <p:spPr>
-          <a:xfrm>
-            <a:off x="457200" y="2953512"/>
-            <a:ext cx="2670048" cy="640080"/>
-          </a:xfrm>
-          <a:prstGeom prst="rect">
-            <a:avLst/>
-          </a:prstGeom>
-          <a:noFill/>
-          <a:ln/>
-        </p:spPr>
-        <p:txBody>
-          <a:bodyPr wrap="square" lIns="0" tIns="0" rIns="0" bIns="0" rtlCol="0" anchor="ctr"/>
-          <a:lstStyle/>
-          <a:p>
-            <a:pPr algn="ctr" indent="0" marL="0">
-              <a:buNone/>
-            </a:pPr>
-            <a:r>
-              <a:rPr lang="en-US" sz="1250" dirty="0">
-                <a:solidFill>
-                  <a:srgbClr val="5B7179"/>
-                </a:solidFill>
-                <a:latin typeface="Calibri" pitchFamily="34" charset="0"/>
-                <a:ea typeface="Calibri" pitchFamily="34" charset="-122"/>
-                <a:cs typeface="Calibri" pitchFamily="34" charset="-120"/>
-              </a:rPr>
-              <a:t>coût/image aujourd'hui (300 € / 1 500)</a:t>
-            </a:r>
-            <a:endParaRPr lang="en-US" sz="1250" dirty="0"/>
-          </a:p>
-        </p:txBody>
-      </p:sp>
-      <p:sp>
-        <p:nvSpPr>
-          <p:cNvPr id="9" name="Shape 6"/>
-          <p:cNvSpPr/>
-          <p:nvPr/>
-        </p:nvSpPr>
-        <p:spPr>
-          <a:xfrm>
-            <a:off x="3236976" y="1828800"/>
-            <a:ext cx="2670048" cy="2103120"/>
-          </a:xfrm>
-          <a:prstGeom prst="roundRect">
-            <a:avLst>
-              <a:gd name="adj" fmla="val 3478"/>
-            </a:avLst>
+          <p:cNvPr id="6" name="Shape 3"/>
+          <p:cNvSpPr/>
+          <p:nvPr/>
+        </p:nvSpPr>
+        <p:spPr>
+          <a:xfrm>
+            <a:off x="685800" y="1481328"/>
+            <a:ext cx="548640" cy="548640"/>
+          </a:xfrm>
+          <a:prstGeom prst="ellipse">
+            <a:avLst/>
           </a:prstGeom>
           <a:solidFill>
-            <a:srgbClr val="EFF6F7"/>
+            <a:srgbClr val="E4572E"/>
           </a:solidFill>
           <a:ln/>
           <a:effectLst>
@@ -7879,16 +8576,40 @@
           </a:effectLst>
         </p:spPr>
       </p:sp>
-      <p:sp>
-        <p:nvSpPr>
-          <p:cNvPr id="10" name="Text 7"/>
-          <p:cNvSpPr/>
-          <p:nvPr/>
-        </p:nvSpPr>
-        <p:spPr>
-          <a:xfrm>
-            <a:off x="3236976" y="2240280"/>
-            <a:ext cx="2670048" cy="731520"/>
+      <p:pic>
+        <p:nvPicPr>
+          <p:cNvPr id="7" name="Image 1" descr="preencoded.png">    </p:cNvPr>
+          <p:cNvPicPr>
+            <a:picLocks noChangeAspect="1"/>
+          </p:cNvPicPr>
+          <p:nvPr/>
+        </p:nvPicPr>
+        <p:blipFill>
+          <a:blip r:embed="rId2"/>
+          <a:stretch>
+            <a:fillRect/>
+          </a:stretch>
+        </p:blipFill>
+        <p:spPr>
+          <a:xfrm>
+            <a:off x="813816" y="1609344"/>
+            <a:ext cx="292608" cy="292608"/>
+          </a:xfrm>
+          <a:prstGeom prst="rect">
+            <a:avLst/>
+          </a:prstGeom>
+        </p:spPr>
+      </p:pic>
+      <p:sp>
+        <p:nvSpPr>
+          <p:cNvPr id="8" name="Text 4"/>
+          <p:cNvSpPr/>
+          <p:nvPr/>
+        </p:nvSpPr>
+        <p:spPr>
+          <a:xfrm>
+            <a:off x="1371600" y="1517904"/>
+            <a:ext cx="3017520" cy="502920"/>
           </a:xfrm>
           <a:prstGeom prst="rect">
             <a:avLst/>
@@ -7900,34 +8621,34 @@
           <a:bodyPr wrap="square" lIns="0" tIns="0" rIns="0" bIns="0" rtlCol="0" anchor="ctr"/>
           <a:lstStyle/>
           <a:p>
-            <a:pPr algn="ctr" indent="0" marL="0">
-              <a:buNone/>
-            </a:pPr>
-            <a:r>
-              <a:rPr lang="en-US" sz="4000" b="1" dirty="0">
-                <a:solidFill>
-                  <a:srgbClr val="0C7B8C"/>
-                </a:solidFill>
-                <a:latin typeface="Calibri" pitchFamily="34" charset="0"/>
-                <a:ea typeface="Calibri" pitchFamily="34" charset="-122"/>
-                <a:cs typeface="Calibri" pitchFamily="34" charset="-120"/>
-              </a:rPr>
-              <a:t>0,00125 €</a:t>
-            </a:r>
-            <a:endParaRPr lang="en-US" sz="4000" dirty="0"/>
-          </a:p>
-        </p:txBody>
-      </p:sp>
-      <p:sp>
-        <p:nvSpPr>
-          <p:cNvPr id="11" name="Text 8"/>
-          <p:cNvSpPr/>
-          <p:nvPr/>
-        </p:nvSpPr>
-        <p:spPr>
-          <a:xfrm>
-            <a:off x="3236976" y="2953512"/>
-            <a:ext cx="2670048" cy="640080"/>
+            <a:pPr indent="0" marL="0">
+              <a:buNone/>
+            </a:pPr>
+            <a:r>
+              <a:rPr lang="en-US" sz="1450" b="1" dirty="0">
+                <a:solidFill>
+                  <a:srgbClr val="1E2D33"/>
+                </a:solidFill>
+                <a:latin typeface="Calibri" pitchFamily="34" charset="0"/>
+                <a:ea typeface="Calibri" pitchFamily="34" charset="-122"/>
+                <a:cs typeface="Calibri" pitchFamily="34" charset="-120"/>
+              </a:rPr>
+              <a:t>Pourquoi le rappel sur le cancer</a:t>
+            </a:r>
+            <a:endParaRPr lang="en-US" sz="1450" dirty="0"/>
+          </a:p>
+        </p:txBody>
+      </p:sp>
+      <p:sp>
+        <p:nvSpPr>
+          <p:cNvPr id="9" name="Text 5"/>
+          <p:cNvSpPr/>
+          <p:nvPr/>
+        </p:nvSpPr>
+        <p:spPr>
+          <a:xfrm>
+            <a:off x="685800" y="2194560"/>
+            <a:ext cx="3611880" cy="2286000"/>
           </a:xfrm>
           <a:prstGeom prst="rect">
             <a:avLst/>
@@ -7939,38 +8660,81 @@
           <a:bodyPr wrap="square" lIns="0" tIns="0" rIns="0" bIns="0" rtlCol="0" anchor="ctr"/>
           <a:lstStyle/>
           <a:p>
-            <a:pPr algn="ctr" indent="0" marL="0">
+            <a:pPr indent="0" marL="0">
+              <a:spcAft>
+                <a:spcPts val="900"/>
+              </a:spcAft>
               <a:buNone/>
             </a:pPr>
             <a:r>
               <a:rPr lang="en-US" sz="1250" dirty="0">
                 <a:solidFill>
-                  <a:srgbClr val="5B7179"/>
-                </a:solidFill>
-                <a:latin typeface="Calibri" pitchFamily="34" charset="0"/>
-                <a:ea typeface="Calibri" pitchFamily="34" charset="-122"/>
-                <a:cs typeface="Calibri" pitchFamily="34" charset="-120"/>
-              </a:rPr>
-              <a:t>coût/image visé (5 000 € / 4 M)</a:t>
+                  <a:srgbClr val="1E2D33"/>
+                </a:solidFill>
+                <a:latin typeface="Calibri" pitchFamily="34" charset="0"/>
+                <a:ea typeface="Calibri" pitchFamily="34" charset="-122"/>
+                <a:cs typeface="Calibri" pitchFamily="34" charset="-120"/>
+              </a:rPr>
+              <a:t>Faux négatif = tumeur manquée = patient non pris en charge. C'est l'erreur la plus grave.</a:t>
             </a:r>
             <a:endParaRPr lang="en-US" sz="1250" dirty="0"/>
           </a:p>
-        </p:txBody>
-      </p:sp>
-      <p:sp>
-        <p:nvSpPr>
-          <p:cNvPr id="12" name="Shape 9"/>
-          <p:cNvSpPr/>
-          <p:nvPr/>
-        </p:nvSpPr>
-        <p:spPr>
-          <a:xfrm>
-            <a:off x="6016752" y="1828800"/>
-            <a:ext cx="2670048" cy="2103120"/>
+          <a:p>
+            <a:pPr indent="0" marL="0">
+              <a:spcAft>
+                <a:spcPts val="900"/>
+              </a:spcAft>
+              <a:buNone/>
+            </a:pPr>
+            <a:r>
+              <a:rPr lang="en-US" sz="1250" dirty="0">
+                <a:solidFill>
+                  <a:srgbClr val="1E2D33"/>
+                </a:solidFill>
+                <a:latin typeface="Calibri" pitchFamily="34" charset="0"/>
+                <a:ea typeface="Calibri" pitchFamily="34" charset="-122"/>
+                <a:cs typeface="Calibri" pitchFamily="34" charset="-120"/>
+              </a:rPr>
+              <a:t>Une fausse alerte (faux positif) coûte un examen complémentaire — bien moins lourd.</a:t>
+            </a:r>
+            <a:endParaRPr lang="en-US" sz="1250" dirty="0"/>
+          </a:p>
+          <a:p>
+            <a:pPr indent="0" marL="0">
+              <a:spcAft>
+                <a:spcPts val="900"/>
+              </a:spcAft>
+              <a:buNone/>
+            </a:pPr>
+            <a:r>
+              <a:rPr lang="en-US" sz="1250" dirty="0">
+                <a:solidFill>
+                  <a:srgbClr val="1E2D33"/>
+                </a:solidFill>
+                <a:latin typeface="Calibri" pitchFamily="34" charset="0"/>
+                <a:ea typeface="Calibri" pitchFamily="34" charset="-122"/>
+                <a:cs typeface="Calibri" pitchFamily="34" charset="-120"/>
+              </a:rPr>
+              <a:t>→ On optimise le rappel cancer, F1 comme compromis. L'accuracy seule serait trompeuse.</a:t>
+            </a:r>
+            <a:endParaRPr lang="en-US" sz="1250" dirty="0"/>
+          </a:p>
+        </p:txBody>
+      </p:sp>
+      <p:sp>
+        <p:nvSpPr>
+          <p:cNvPr id="10" name="Shape 6"/>
+          <p:cNvSpPr/>
+          <p:nvPr/>
+        </p:nvSpPr>
+        <p:spPr>
+          <a:xfrm>
+            <a:off x="4663440" y="1280160"/>
+            <a:ext cx="4023360" cy="3337560"/>
           </a:xfrm>
           <a:prstGeom prst="roundRect">
             <a:avLst>
-              <a:gd name="adj" fmla="val 3478"/>
+              <a:gd name="adj" fmla="val 2192"/>
             </a:avLst>
           </a:prstGeom>
           <a:solidFill>
@@ -7988,14 +8752,65 @@
       </p:sp>
       <p:sp>
         <p:nvSpPr>
-          <p:cNvPr id="13" name="Text 10"/>
-          <p:cNvSpPr/>
-          <p:nvPr/>
-        </p:nvSpPr>
-        <p:spPr>
-          <a:xfrm>
-            <a:off x="6016752" y="2240280"/>
-            <a:ext cx="2670048" cy="731520"/>
+          <p:cNvPr id="11" name="Shape 7"/>
+          <p:cNvSpPr/>
+          <p:nvPr/>
+        </p:nvSpPr>
+        <p:spPr>
+          <a:xfrm>
+            <a:off x="4892040" y="1481328"/>
+            <a:ext cx="548640" cy="548640"/>
+          </a:xfrm>
+          <a:prstGeom prst="ellipse">
+            <a:avLst/>
+          </a:prstGeom>
+          <a:solidFill>
+            <a:srgbClr val="0C7B8C"/>
+          </a:solidFill>
+          <a:ln/>
+          <a:effectLst>
+            <a:outerShdw sx="100000" sy="100000" kx="0" ky="0" algn="bl" rotWithShape="0" blurRad="88900" dist="38100" dir="5400000">
+              <a:srgbClr val="000000">
+                <a:alpha val="13000"/>
+              </a:srgbClr>
+            </a:outerShdw>
+          </a:effectLst>
+        </p:spPr>
+      </p:sp>
+      <p:pic>
+        <p:nvPicPr>
+          <p:cNvPr id="12" name="Image 2" descr="preencoded.png">    </p:cNvPr>
+          <p:cNvPicPr>
+            <a:picLocks noChangeAspect="1"/>
+          </p:cNvPicPr>
+          <p:nvPr/>
+        </p:nvPicPr>
+        <p:blipFill>
+          <a:blip r:embed="rId3"/>
+          <a:stretch>
+            <a:fillRect/>
+          </a:stretch>
+        </p:blipFill>
+        <p:spPr>
+          <a:xfrm>
+            <a:off x="5020056" y="1609344"/>
+            <a:ext cx="292608" cy="292608"/>
+          </a:xfrm>
+          <a:prstGeom prst="rect">
+            <a:avLst/>
+          </a:prstGeom>
+        </p:spPr>
+      </p:pic>
+      <p:sp>
+        <p:nvSpPr>
+          <p:cNvPr id="13" name="Text 8"/>
+          <p:cNvSpPr/>
+          <p:nvPr/>
+        </p:nvSpPr>
+        <p:spPr>
+          <a:xfrm>
+            <a:off x="5577840" y="1517904"/>
+            <a:ext cx="2926080" cy="502920"/>
           </a:xfrm>
           <a:prstGeom prst="rect">
             <a:avLst/>
@@ -8007,34 +8822,34 @@
           <a:bodyPr wrap="square" lIns="0" tIns="0" rIns="0" bIns="0" rtlCol="0" anchor="ctr"/>
           <a:lstStyle/>
           <a:p>
-            <a:pPr algn="ctr" indent="0" marL="0">
-              <a:buNone/>
-            </a:pPr>
-            <a:r>
-              <a:rPr lang="en-US" sz="4000" b="1" dirty="0">
-                <a:solidFill>
-                  <a:srgbClr val="E4572E"/>
-                </a:solidFill>
-                <a:latin typeface="Calibri" pitchFamily="34" charset="0"/>
-                <a:ea typeface="Calibri" pitchFamily="34" charset="-122"/>
-                <a:cs typeface="Calibri" pitchFamily="34" charset="-120"/>
-              </a:rPr>
-              <a:t>× 160</a:t>
-            </a:r>
-            <a:endParaRPr lang="en-US" sz="4000" dirty="0"/>
-          </a:p>
-        </p:txBody>
-      </p:sp>
-      <p:sp>
-        <p:nvSpPr>
-          <p:cNvPr id="14" name="Text 11"/>
-          <p:cNvSpPr/>
-          <p:nvPr/>
-        </p:nvSpPr>
-        <p:spPr>
-          <a:xfrm>
-            <a:off x="6016752" y="2953512"/>
-            <a:ext cx="2670048" cy="640080"/>
+            <a:pPr indent="0" marL="0">
+              <a:buNone/>
+            </a:pPr>
+            <a:r>
+              <a:rPr lang="en-US" sz="1450" b="1" dirty="0">
+                <a:solidFill>
+                  <a:srgbClr val="1E2D33"/>
+                </a:solidFill>
+                <a:latin typeface="Calibri" pitchFamily="34" charset="0"/>
+                <a:ea typeface="Calibri" pitchFamily="34" charset="-122"/>
+                <a:cs typeface="Calibri" pitchFamily="34" charset="-120"/>
+              </a:rPr>
+              <a:t>Definition of done</a:t>
+            </a:r>
+            <a:endParaRPr lang="en-US" sz="1450" dirty="0"/>
+          </a:p>
+        </p:txBody>
+      </p:sp>
+      <p:sp>
+        <p:nvSpPr>
+          <p:cNvPr id="14" name="Text 9"/>
+          <p:cNvSpPr/>
+          <p:nvPr/>
+        </p:nvSpPr>
+        <p:spPr>
+          <a:xfrm>
+            <a:off x="4892040" y="2194560"/>
+            <a:ext cx="3611880" cy="2286000"/>
           </a:xfrm>
           <a:prstGeom prst="rect">
             <a:avLst/>
@@ -8046,58 +8861,86 @@
           <a:bodyPr wrap="square" lIns="0" tIns="0" rIns="0" bIns="0" rtlCol="0" anchor="ctr"/>
           <a:lstStyle/>
           <a:p>
-            <a:pPr algn="ctr" indent="0" marL="0">
-              <a:buNone/>
+            <a:pPr marL="342900" indent="-342900">
+              <a:spcAft>
+                <a:spcPts val="900"/>
+              </a:spcAft>
+              <a:buSzPct val="100000"/>
+              <a:buChar char="•"/>
             </a:pPr>
             <a:r>
               <a:rPr lang="en-US" sz="1250" dirty="0">
                 <a:solidFill>
-                  <a:srgbClr val="5B7179"/>
-                </a:solidFill>
-                <a:latin typeface="Calibri" pitchFamily="34" charset="0"/>
-                <a:ea typeface="Calibri" pitchFamily="34" charset="-122"/>
-                <a:cs typeface="Calibri" pitchFamily="34" charset="-120"/>
-              </a:rPr>
-              <a:t>réduction de coût par image exigée</a:t>
+                  <a:srgbClr val="1E2D33"/>
+                </a:solidFill>
+                <a:latin typeface="Calibri" pitchFamily="34" charset="0"/>
+                <a:ea typeface="Calibri" pitchFamily="34" charset="-122"/>
+                <a:cs typeface="Calibri" pitchFamily="34" charset="-120"/>
+              </a:rPr>
+              <a:t>Protocole sans aucune fuite test ↔ entraînement (vérifié : 0)</a:t>
             </a:r>
             <a:endParaRPr lang="en-US" sz="1250" dirty="0"/>
           </a:p>
-        </p:txBody>
-      </p:sp>
-      <p:sp>
-        <p:nvSpPr>
-          <p:cNvPr id="15" name="Text 12"/>
-          <p:cNvSpPr/>
-          <p:nvPr/>
-        </p:nvSpPr>
-        <p:spPr>
-          <a:xfrm>
-            <a:off x="457200" y="4114800"/>
-            <a:ext cx="8229600" cy="822960"/>
-          </a:xfrm>
-          <a:prstGeom prst="rect">
-            <a:avLst/>
-          </a:prstGeom>
-          <a:noFill/>
-          <a:ln/>
-        </p:spPr>
-        <p:txBody>
-          <a:bodyPr wrap="square" lIns="0" tIns="0" rIns="0" bIns="0" rtlCol="0" anchor="ctr"/>
-          <a:lstStyle/>
-          <a:p>
-            <a:pPr indent="0" marL="0">
-              <a:buNone/>
-            </a:pPr>
-            <a:r>
-              <a:rPr lang="en-US" sz="1250" i="1" dirty="0">
-                <a:solidFill>
-                  <a:srgbClr val="5B7179"/>
-                </a:solidFill>
-                <a:latin typeface="Calibri" pitchFamily="34" charset="0"/>
-                <a:ea typeface="Calibri" pitchFamily="34" charset="-122"/>
-                <a:cs typeface="Calibri" pitchFamily="34" charset="-120"/>
-              </a:rPr>
-              <a:t>Le calcul pur de compute (inférence sur GPU) tient largement dans 5 000 €. La contrainte n'est donc pas le budget mais la QUALITÉ des labels produits : à 0,68 d'accuracy au clustering, propager tel quel à 4 M d'images amplifierait le bruit.</a:t>
+          <a:p>
+            <a:pPr marL="342900" indent="-342900">
+              <a:spcAft>
+                <a:spcPts val="900"/>
+              </a:spcAft>
+              <a:buSzPct val="100000"/>
+              <a:buChar char="•"/>
+            </a:pPr>
+            <a:r>
+              <a:rPr lang="en-US" sz="1250" dirty="0">
+                <a:solidFill>
+                  <a:srgbClr val="1E2D33"/>
+                </a:solidFill>
+                <a:latin typeface="Calibri" pitchFamily="34" charset="0"/>
+                <a:ea typeface="Calibri" pitchFamily="34" charset="-122"/>
+                <a:cs typeface="Calibri" pitchFamily="34" charset="-120"/>
+              </a:rPr>
+              <a:t>Rappel &amp; F1 cancer rapportés sur un test jamais vu</a:t>
+            </a:r>
+            <a:endParaRPr lang="en-US" sz="1250" dirty="0"/>
+          </a:p>
+          <a:p>
+            <a:pPr marL="342900" indent="-342900">
+              <a:spcAft>
+                <a:spcPts val="900"/>
+              </a:spcAft>
+              <a:buSzPct val="100000"/>
+              <a:buChar char="•"/>
+            </a:pPr>
+            <a:r>
+              <a:rPr lang="en-US" sz="1250" dirty="0">
+                <a:solidFill>
+                  <a:srgbClr val="1E2D33"/>
+                </a:solidFill>
+                <a:latin typeface="Calibri" pitchFamily="34" charset="0"/>
+                <a:ea typeface="Calibri" pitchFamily="34" charset="-122"/>
+                <a:cs typeface="Calibri" pitchFamily="34" charset="-120"/>
+              </a:rPr>
+              <a:t>Comparaison chiffrée supervisé vs semi, moyennée sur plusieurs graines</a:t>
+            </a:r>
+            <a:endParaRPr lang="en-US" sz="1250" dirty="0"/>
+          </a:p>
+          <a:p>
+            <a:pPr marL="342900" indent="-342900">
+              <a:spcAft>
+                <a:spcPts val="900"/>
+              </a:spcAft>
+              <a:buSzPct val="100000"/>
+              <a:buChar char="•"/>
+            </a:pPr>
+            <a:r>
+              <a:rPr lang="en-US" sz="1250" dirty="0">
+                <a:solidFill>
+                  <a:srgbClr val="1E2D33"/>
+                </a:solidFill>
+                <a:latin typeface="Calibri" pitchFamily="34" charset="0"/>
+                <a:ea typeface="Calibri" pitchFamily="34" charset="-122"/>
+                <a:cs typeface="Calibri" pitchFamily="34" charset="-120"/>
+              </a:rPr>
+              <a:t>Succès « fort » = le semi égale ou dépasse le supervisé en rappel cancer</a:t>
             </a:r>
             <a:endParaRPr lang="en-US" sz="1250" dirty="0"/>
           </a:p>

</xml_diff>